<commit_message>
U2L1: workflow vs agency, support-ticket triage domain
</commit_message>
<xml_diff>
--- a/slides/CSE476_Lecture_Zero.pptx
+++ b/slides/CSE476_Lecture_Zero.pptx
@@ -56,9 +56,13 @@
     <p:sldId id="304" r:id="rId50"/>
     <p:sldId id="305" r:id="rId51"/>
     <p:sldId id="306" r:id="rId52"/>
+    <p:sldId id="307" r:id="rId53"/>
+    <p:sldId id="308" r:id="rId54"/>
+    <p:sldId id="309" r:id="rId55"/>
+    <p:sldId id="310" r:id="rId56"/>
   </p:sldIdLst>
   <p:notesMasterIdLst>
-    <p:notesMasterId r:id="rId53"/>
+    <p:notesMasterId r:id="rId57"/>
   </p:notesMasterIdLst>
   <p:sldSz cx="12192000" cy="6858000"/>
   <p:notesSz cx="6858000" cy="12192000"/>
@@ -4160,7 +4164,7 @@
           <a:p>
             <a:r>
               <a:rPr lang="en-US" dirty="0"/>
-              <a:t>TEACHING NOTE (do not say): insert your actual CA count, MTE and ETE weightings and practical marks before delivering. The card structure holds whatever numbers your scheme uses.</a:t>
+              <a:t>Attendance 5, Practicals 45, ETP 50, total 100. No written midterm or end term. Everything gradeable is practical and defended, so say clearly that copied code without understanding does not survive the viva.</a:t>
             </a:r>
             <a:endParaRPr lang="en-US" dirty="0"/>
           </a:p>
@@ -4336,7 +4340,7 @@
           <a:p>
             <a:r>
               <a:rPr lang="en-US" dirty="0"/>
-              <a:t/>
+              <a:t>These slides are the university record. I move through them quickly in class, but they stay in the deck you keep, because you will want the exact numbers later.</a:t>
             </a:r>
             <a:endParaRPr lang="en-US" dirty="0"/>
           </a:p>
@@ -4512,7 +4516,7 @@
           <a:p>
             <a:r>
               <a:rPr lang="en-US" dirty="0"/>
-              <a:t>End here. Do not add a thank you slide. Move straight into the setup checklist and start helping people install things, because that is the highest value use of the remaining time.</a:t>
+              <a:t>The books are references, not something we follow chapter by chapter. Our real material is the repository and the decks. Say that so nobody buys the book expecting it to match the course exactly.</a:t>
             </a:r>
             <a:endParaRPr lang="en-US" dirty="0"/>
           </a:p>
@@ -4600,7 +4604,7 @@
           <a:p>
             <a:r>
               <a:rPr lang="en-US" dirty="0"/>
-              <a:t/>
+              <a:t>Read CO1 and CO6 aloud at least. The rest they can read. The point to land is that all six are build verbs, which sets up why the assessment is practical heavy.</a:t>
             </a:r>
             <a:endParaRPr lang="en-US" dirty="0"/>
           </a:p>
@@ -4624,6 +4628,358 @@
             <a:fld id="{F7021451-1387-4CA6-816F-3879F97B5CBC}" type="slidenum">
               <a:rPr lang="en-US"/>
               <a:t>51</a:t>
+            </a:fld>
+            <a:endParaRPr lang="en-US"/>
+          </a:p>
+        </p:txBody>
+      </p:sp>
+    </p:spTree>
+    <p:extLst>
+      <p:ext uri="{BB962C8B-B14F-4D97-AF65-F5344CB8AC3E}">
+        <p14:creationId xmlns:p14="http://schemas.microsoft.com/office/powerpoint/2010/main" val="1024086991"/>
+      </p:ext>
+    </p:extLst>
+  </p:cSld>
+  <p:clrMapOvr>
+    <a:masterClrMapping/>
+  </p:clrMapOvr>
+</p:notes>
+</file>
+
+<file path=ppt/notesSlides/notesSlide52.xml><?xml version="1.0" encoding="utf-8"?>
+<p:notes xmlns:a="http://schemas.openxmlformats.org/drawingml/2006/main" xmlns:r="http://schemas.openxmlformats.org/officeDocument/2006/relationships" xmlns:p="http://schemas.openxmlformats.org/presentationml/2006/main">
+  <p:cSld>
+    <p:spTree>
+      <p:nvGrpSpPr>
+        <p:cNvPr id="1" name=""/>
+        <p:cNvGrpSpPr/>
+        <p:nvPr/>
+      </p:nvGrpSpPr>
+      <p:grpSpPr>
+        <a:xfrm>
+          <a:off x="0" y="0"/>
+          <a:ext cx="0" cy="0"/>
+          <a:chOff x="0" y="0"/>
+          <a:chExt cx="0" cy="0"/>
+        </a:xfrm>
+      </p:grpSpPr>
+      <p:sp>
+        <p:nvSpPr>
+          <p:cNvPr id="2" name="Slide Image Placeholder 1"/>
+          <p:cNvSpPr>
+            <a:spLocks noGrp="1" noRot="1" noChangeAspect="1"/>
+          </p:cNvSpPr>
+          <p:nvPr>
+            <p:ph type="sldImg"/>
+          </p:nvPr>
+        </p:nvSpPr>
+        <p:spPr/>
+      </p:sp>
+      <p:sp>
+        <p:nvSpPr>
+          <p:cNvPr id="3" name="Notes Placeholder 2"/>
+          <p:cNvSpPr>
+            <a:spLocks noGrp="1"/>
+          </p:cNvSpPr>
+          <p:nvPr>
+            <p:ph type="body" idx="1"/>
+          </p:nvPr>
+        </p:nvSpPr>
+        <p:spPr/>
+        <p:txBody>
+          <a:bodyPr/>
+          <a:lstStyle/>
+          <a:p>
+            <a:r>
+              <a:rPr lang="en-US" dirty="0"/>
+              <a:t>These week numbers are from the official plan. Confirm them against the current academic calendar before delivering, since term dates shift year to year.</a:t>
+            </a:r>
+            <a:endParaRPr lang="en-US" dirty="0"/>
+          </a:p>
+        </p:txBody>
+      </p:sp>
+      <p:sp>
+        <p:nvSpPr>
+          <p:cNvPr id="4" name="Slide Number Placeholder 3"/>
+          <p:cNvSpPr>
+            <a:spLocks noGrp="1"/>
+          </p:cNvSpPr>
+          <p:nvPr>
+            <p:ph type="sldNum" sz="quarter" idx="10"/>
+          </p:nvPr>
+        </p:nvSpPr>
+        <p:spPr/>
+        <p:txBody>
+          <a:bodyPr/>
+          <a:lstStyle/>
+          <a:p>
+            <a:fld id="{F7021451-1387-4CA6-816F-3879F97B5CBC}" type="slidenum">
+              <a:rPr lang="en-US"/>
+              <a:t>52</a:t>
+            </a:fld>
+            <a:endParaRPr lang="en-US"/>
+          </a:p>
+        </p:txBody>
+      </p:sp>
+    </p:spTree>
+    <p:extLst>
+      <p:ext uri="{BB962C8B-B14F-4D97-AF65-F5344CB8AC3E}">
+        <p14:creationId xmlns:p14="http://schemas.microsoft.com/office/powerpoint/2010/main" val="1024086991"/>
+      </p:ext>
+    </p:extLst>
+  </p:cSld>
+  <p:clrMapOvr>
+    <a:masterClrMapping/>
+  </p:clrMapOvr>
+</p:notes>
+</file>
+
+<file path=ppt/notesSlides/notesSlide53.xml><?xml version="1.0" encoding="utf-8"?>
+<p:notes xmlns:a="http://schemas.openxmlformats.org/drawingml/2006/main" xmlns:r="http://schemas.openxmlformats.org/officeDocument/2006/relationships" xmlns:p="http://schemas.openxmlformats.org/presentationml/2006/main">
+  <p:cSld>
+    <p:spTree>
+      <p:nvGrpSpPr>
+        <p:cNvPr id="1" name=""/>
+        <p:cNvGrpSpPr/>
+        <p:nvPr/>
+      </p:nvGrpSpPr>
+      <p:grpSpPr>
+        <a:xfrm>
+          <a:off x="0" y="0"/>
+          <a:ext cx="0" cy="0"/>
+          <a:chOff x="0" y="0"/>
+          <a:chExt cx="0" cy="0"/>
+        </a:xfrm>
+      </p:grpSpPr>
+      <p:sp>
+        <p:nvSpPr>
+          <p:cNvPr id="2" name="Slide Image Placeholder 1"/>
+          <p:cNvSpPr>
+            <a:spLocks noGrp="1" noRot="1" noChangeAspect="1"/>
+          </p:cNvSpPr>
+          <p:nvPr>
+            <p:ph type="sldImg"/>
+          </p:nvPr>
+        </p:nvSpPr>
+        <p:spPr/>
+      </p:sp>
+      <p:sp>
+        <p:nvSpPr>
+          <p:cNvPr id="3" name="Notes Placeholder 2"/>
+          <p:cNvSpPr>
+            <a:spLocks noGrp="1"/>
+          </p:cNvSpPr>
+          <p:nvPr>
+            <p:ph type="body" idx="1"/>
+          </p:nvPr>
+        </p:nvSpPr>
+        <p:spPr/>
+        <p:txBody>
+          <a:bodyPr/>
+          <a:lstStyle/>
+          <a:p>
+            <a:r>
+              <a:rPr lang="en-US" dirty="0"/>
+              <a:t/>
+            </a:r>
+            <a:endParaRPr lang="en-US" dirty="0"/>
+          </a:p>
+        </p:txBody>
+      </p:sp>
+      <p:sp>
+        <p:nvSpPr>
+          <p:cNvPr id="4" name="Slide Number Placeholder 3"/>
+          <p:cNvSpPr>
+            <a:spLocks noGrp="1"/>
+          </p:cNvSpPr>
+          <p:nvPr>
+            <p:ph type="sldNum" sz="quarter" idx="10"/>
+          </p:nvPr>
+        </p:nvSpPr>
+        <p:spPr/>
+        <p:txBody>
+          <a:bodyPr/>
+          <a:lstStyle/>
+          <a:p>
+            <a:fld id="{F7021451-1387-4CA6-816F-3879F97B5CBC}" type="slidenum">
+              <a:rPr lang="en-US"/>
+              <a:t>53</a:t>
+            </a:fld>
+            <a:endParaRPr lang="en-US"/>
+          </a:p>
+        </p:txBody>
+      </p:sp>
+    </p:spTree>
+    <p:extLst>
+      <p:ext uri="{BB962C8B-B14F-4D97-AF65-F5344CB8AC3E}">
+        <p14:creationId xmlns:p14="http://schemas.microsoft.com/office/powerpoint/2010/main" val="1024086991"/>
+      </p:ext>
+    </p:extLst>
+  </p:cSld>
+  <p:clrMapOvr>
+    <a:masterClrMapping/>
+  </p:clrMapOvr>
+</p:notes>
+</file>
+
+<file path=ppt/notesSlides/notesSlide54.xml><?xml version="1.0" encoding="utf-8"?>
+<p:notes xmlns:a="http://schemas.openxmlformats.org/drawingml/2006/main" xmlns:r="http://schemas.openxmlformats.org/officeDocument/2006/relationships" xmlns:p="http://schemas.openxmlformats.org/presentationml/2006/main">
+  <p:cSld>
+    <p:spTree>
+      <p:nvGrpSpPr>
+        <p:cNvPr id="1" name=""/>
+        <p:cNvGrpSpPr/>
+        <p:nvPr/>
+      </p:nvGrpSpPr>
+      <p:grpSpPr>
+        <a:xfrm>
+          <a:off x="0" y="0"/>
+          <a:ext cx="0" cy="0"/>
+          <a:chOff x="0" y="0"/>
+          <a:chExt cx="0" cy="0"/>
+        </a:xfrm>
+      </p:grpSpPr>
+      <p:sp>
+        <p:nvSpPr>
+          <p:cNvPr id="2" name="Slide Image Placeholder 1"/>
+          <p:cNvSpPr>
+            <a:spLocks noGrp="1" noRot="1" noChangeAspect="1"/>
+          </p:cNvSpPr>
+          <p:nvPr>
+            <p:ph type="sldImg"/>
+          </p:nvPr>
+        </p:nvSpPr>
+        <p:spPr/>
+      </p:sp>
+      <p:sp>
+        <p:nvSpPr>
+          <p:cNvPr id="3" name="Notes Placeholder 2"/>
+          <p:cNvSpPr>
+            <a:spLocks noGrp="1"/>
+          </p:cNvSpPr>
+          <p:nvPr>
+            <p:ph type="body" idx="1"/>
+          </p:nvPr>
+        </p:nvSpPr>
+        <p:spPr/>
+        <p:txBody>
+          <a:bodyPr/>
+          <a:lstStyle/>
+          <a:p>
+            <a:r>
+              <a:rPr lang="en-US" dirty="0"/>
+              <a:t>End here. Do not add a thank you slide. Move straight into the setup checklist and start helping people install things, because that is the highest value use of the remaining time.</a:t>
+            </a:r>
+            <a:endParaRPr lang="en-US" dirty="0"/>
+          </a:p>
+        </p:txBody>
+      </p:sp>
+      <p:sp>
+        <p:nvSpPr>
+          <p:cNvPr id="4" name="Slide Number Placeholder 3"/>
+          <p:cNvSpPr>
+            <a:spLocks noGrp="1"/>
+          </p:cNvSpPr>
+          <p:nvPr>
+            <p:ph type="sldNum" sz="quarter" idx="10"/>
+          </p:nvPr>
+        </p:nvSpPr>
+        <p:spPr/>
+        <p:txBody>
+          <a:bodyPr/>
+          <a:lstStyle/>
+          <a:p>
+            <a:fld id="{F7021451-1387-4CA6-816F-3879F97B5CBC}" type="slidenum">
+              <a:rPr lang="en-US"/>
+              <a:t>54</a:t>
+            </a:fld>
+            <a:endParaRPr lang="en-US"/>
+          </a:p>
+        </p:txBody>
+      </p:sp>
+    </p:spTree>
+    <p:extLst>
+      <p:ext uri="{BB962C8B-B14F-4D97-AF65-F5344CB8AC3E}">
+        <p14:creationId xmlns:p14="http://schemas.microsoft.com/office/powerpoint/2010/main" val="1024086991"/>
+      </p:ext>
+    </p:extLst>
+  </p:cSld>
+  <p:clrMapOvr>
+    <a:masterClrMapping/>
+  </p:clrMapOvr>
+</p:notes>
+</file>
+
+<file path=ppt/notesSlides/notesSlide55.xml><?xml version="1.0" encoding="utf-8"?>
+<p:notes xmlns:a="http://schemas.openxmlformats.org/drawingml/2006/main" xmlns:r="http://schemas.openxmlformats.org/officeDocument/2006/relationships" xmlns:p="http://schemas.openxmlformats.org/presentationml/2006/main">
+  <p:cSld>
+    <p:spTree>
+      <p:nvGrpSpPr>
+        <p:cNvPr id="1" name=""/>
+        <p:cNvGrpSpPr/>
+        <p:nvPr/>
+      </p:nvGrpSpPr>
+      <p:grpSpPr>
+        <a:xfrm>
+          <a:off x="0" y="0"/>
+          <a:ext cx="0" cy="0"/>
+          <a:chOff x="0" y="0"/>
+          <a:chExt cx="0" cy="0"/>
+        </a:xfrm>
+      </p:grpSpPr>
+      <p:sp>
+        <p:nvSpPr>
+          <p:cNvPr id="2" name="Slide Image Placeholder 1"/>
+          <p:cNvSpPr>
+            <a:spLocks noGrp="1" noRot="1" noChangeAspect="1"/>
+          </p:cNvSpPr>
+          <p:nvPr>
+            <p:ph type="sldImg"/>
+          </p:nvPr>
+        </p:nvSpPr>
+        <p:spPr/>
+      </p:sp>
+      <p:sp>
+        <p:nvSpPr>
+          <p:cNvPr id="3" name="Notes Placeholder 2"/>
+          <p:cNvSpPr>
+            <a:spLocks noGrp="1"/>
+          </p:cNvSpPr>
+          <p:nvPr>
+            <p:ph type="body" idx="1"/>
+          </p:nvPr>
+        </p:nvSpPr>
+        <p:spPr/>
+        <p:txBody>
+          <a:bodyPr/>
+          <a:lstStyle/>
+          <a:p>
+            <a:r>
+              <a:rPr lang="en-US" dirty="0"/>
+              <a:t/>
+            </a:r>
+            <a:endParaRPr lang="en-US" dirty="0"/>
+          </a:p>
+        </p:txBody>
+      </p:sp>
+      <p:sp>
+        <p:nvSpPr>
+          <p:cNvPr id="4" name="Slide Number Placeholder 3"/>
+          <p:cNvSpPr>
+            <a:spLocks noGrp="1"/>
+          </p:cNvSpPr>
+          <p:nvPr>
+            <p:ph type="sldNum" sz="quarter" idx="10"/>
+          </p:nvPr>
+        </p:nvSpPr>
+        <p:spPr/>
+        <p:txBody>
+          <a:bodyPr/>
+          <a:lstStyle/>
+          <a:p>
+            <a:fld id="{F7021451-1387-4CA6-816F-3879F97B5CBC}" type="slidenum">
+              <a:rPr lang="en-US"/>
+              <a:t>55</a:t>
             </a:fld>
             <a:endParaRPr lang="en-US"/>
           </a:p>
@@ -25111,7 +25467,7 @@
                 <a:ea typeface="Cambria" pitchFamily="34" charset="-122"/>
                 <a:cs typeface="Cambria" pitchFamily="34" charset="-120"/>
               </a:rPr>
-              <a:t>Assessment</a:t>
+              <a:t>How you are marked</a:t>
             </a:r>
             <a:endParaRPr lang="en-US" sz="2900" dirty="0"/>
           </a:p>
@@ -25125,12 +25481,12 @@
         </p:nvSpPr>
         <p:spPr>
           <a:xfrm>
-            <a:off x="566928" y="1874520"/>
-            <a:ext cx="2546604" cy="2468880"/>
+            <a:off x="566928" y="1828800"/>
+            <a:ext cx="11064240" cy="914400"/>
           </a:xfrm>
           <a:prstGeom prst="roundRect">
             <a:avLst>
-              <a:gd name="adj" fmla="val 3333"/>
+              <a:gd name="adj" fmla="val 9000"/>
             </a:avLst>
           </a:prstGeom>
           <a:solidFill>
@@ -25152,24 +25508,24 @@
         </p:nvSpPr>
         <p:spPr>
           <a:xfrm>
-            <a:off x="804672" y="2075688"/>
-            <a:ext cx="2089404" cy="256032"/>
-          </a:xfrm>
-          <a:prstGeom prst="rect">
-            <a:avLst/>
-          </a:prstGeom>
-          <a:noFill/>
-          <a:ln/>
-        </p:spPr>
-        <p:txBody>
-          <a:bodyPr wrap="square" lIns="0" tIns="0" rIns="0" bIns="0" rtlCol="0" anchor="ctr"/>
-          <a:lstStyle/>
-          <a:p>
-            <a:pPr indent="0" marL="0">
-              <a:buNone/>
-            </a:pPr>
-            <a:r>
-              <a:rPr lang="en-US" sz="1050" b="1" spc="120" kern="0" dirty="0">
+            <a:off x="822960" y="1828800"/>
+            <a:ext cx="2377440" cy="914400"/>
+          </a:xfrm>
+          <a:prstGeom prst="rect">
+            <a:avLst/>
+          </a:prstGeom>
+          <a:noFill/>
+          <a:ln/>
+        </p:spPr>
+        <p:txBody>
+          <a:bodyPr wrap="square" lIns="0" tIns="0" rIns="0" bIns="0" rtlCol="0" anchor="ctr"/>
+          <a:lstStyle/>
+          <a:p>
+            <a:pPr indent="0" marL="0">
+              <a:buNone/>
+            </a:pPr>
+            <a:r>
+              <a:rPr lang="en-US" sz="1250" b="1" spc="120" kern="0" dirty="0">
                 <a:solidFill>
                   <a:srgbClr val="0F766E"/>
                 </a:solidFill>
@@ -25177,9 +25533,9 @@
                 <a:ea typeface="Calibri" pitchFamily="34" charset="-122"/>
                 <a:cs typeface="Calibri" pitchFamily="34" charset="-120"/>
               </a:rPr>
-              <a:t>CONTINUOUS</a:t>
-            </a:r>
-            <a:endParaRPr lang="en-US" sz="1050" dirty="0"/>
+              <a:t>ATTENDANCE</a:t>
+            </a:r>
+            <a:endParaRPr lang="en-US" sz="1250" dirty="0"/>
           </a:p>
         </p:txBody>
       </p:sp>
@@ -25191,27 +25547,24 @@
         </p:nvSpPr>
         <p:spPr>
           <a:xfrm>
-            <a:off x="804672" y="2386584"/>
-            <a:ext cx="2089404" cy="548640"/>
-          </a:xfrm>
-          <a:prstGeom prst="rect">
-            <a:avLst/>
-          </a:prstGeom>
-          <a:noFill/>
-          <a:ln/>
-        </p:spPr>
-        <p:txBody>
-          <a:bodyPr wrap="square" lIns="0" tIns="0" rIns="0" bIns="0" rtlCol="0" anchor="ctr"/>
-          <a:lstStyle/>
-          <a:p>
-            <a:pPr indent="0" marL="0">
-              <a:lnSpc>
-                <a:spcPts val="2100"/>
-              </a:lnSpc>
-              <a:buNone/>
-            </a:pPr>
-            <a:r>
-              <a:rPr lang="en-US" sz="1700" b="1" dirty="0">
+            <a:off x="3108960" y="1828800"/>
+            <a:ext cx="1188720" cy="914400"/>
+          </a:xfrm>
+          <a:prstGeom prst="rect">
+            <a:avLst/>
+          </a:prstGeom>
+          <a:noFill/>
+          <a:ln/>
+        </p:spPr>
+        <p:txBody>
+          <a:bodyPr wrap="square" lIns="0" tIns="0" rIns="0" bIns="0" rtlCol="0" anchor="ctr"/>
+          <a:lstStyle/>
+          <a:p>
+            <a:pPr indent="0" marL="0">
+              <a:buNone/>
+            </a:pPr>
+            <a:r>
+              <a:rPr lang="en-US" sz="3000" b="1" dirty="0">
                 <a:solidFill>
                   <a:srgbClr val="1F2937"/>
                 </a:solidFill>
@@ -25219,9 +25572,9 @@
                 <a:ea typeface="Cambria" pitchFamily="34" charset="-122"/>
                 <a:cs typeface="Cambria" pitchFamily="34" charset="-120"/>
               </a:rPr>
-              <a:t>CA</a:t>
-            </a:r>
-            <a:endParaRPr lang="en-US" sz="1700" dirty="0"/>
+              <a:t>5</a:t>
+            </a:r>
+            <a:endParaRPr lang="en-US" sz="3000" dirty="0"/>
           </a:p>
         </p:txBody>
       </p:sp>
@@ -25233,8 +25586,8 @@
         </p:nvSpPr>
         <p:spPr>
           <a:xfrm>
-            <a:off x="804672" y="2953512"/>
-            <a:ext cx="2089404" cy="1188720"/>
+            <a:off x="4480560" y="1828800"/>
+            <a:ext cx="6858000" cy="914400"/>
           </a:xfrm>
           <a:prstGeom prst="rect">
             <a:avLst/>
@@ -25253,7 +25606,7 @@
               <a:buNone/>
             </a:pPr>
             <a:r>
-              <a:rPr lang="en-US" sz="1250" dirty="0">
+              <a:rPr lang="en-US" sz="1450" dirty="0">
                 <a:solidFill>
                   <a:srgbClr val="6B7280"/>
                 </a:solidFill>
@@ -25261,9 +25614,9 @@
                 <a:ea typeface="Calibri" pitchFamily="34" charset="-122"/>
                 <a:cs typeface="Calibri" pitchFamily="34" charset="-120"/>
               </a:rPr>
-              <a:t>Assessed through the practicals and short in class checks. The practicals are the assessment, not homework attached to it.</a:t>
-            </a:r>
-            <a:endParaRPr lang="en-US" sz="1250" dirty="0"/>
+              <a:t>Show up. Five easy marks for being in the room.</a:t>
+            </a:r>
+            <a:endParaRPr lang="en-US" sz="1450" dirty="0"/>
           </a:p>
         </p:txBody>
       </p:sp>
@@ -25275,12 +25628,12 @@
         </p:nvSpPr>
         <p:spPr>
           <a:xfrm>
-            <a:off x="3406140" y="1874520"/>
-            <a:ext cx="2546604" cy="2468880"/>
+            <a:off x="566928" y="2880360"/>
+            <a:ext cx="11064240" cy="914400"/>
           </a:xfrm>
           <a:prstGeom prst="roundRect">
             <a:avLst>
-              <a:gd name="adj" fmla="val 3333"/>
+              <a:gd name="adj" fmla="val 9000"/>
             </a:avLst>
           </a:prstGeom>
           <a:solidFill>
@@ -25302,24 +25655,24 @@
         </p:nvSpPr>
         <p:spPr>
           <a:xfrm>
-            <a:off x="3643884" y="2075688"/>
-            <a:ext cx="2089404" cy="256032"/>
-          </a:xfrm>
-          <a:prstGeom prst="rect">
-            <a:avLst/>
-          </a:prstGeom>
-          <a:noFill/>
-          <a:ln/>
-        </p:spPr>
-        <p:txBody>
-          <a:bodyPr wrap="square" lIns="0" tIns="0" rIns="0" bIns="0" rtlCol="0" anchor="ctr"/>
-          <a:lstStyle/>
-          <a:p>
-            <a:pPr indent="0" marL="0">
-              <a:buNone/>
-            </a:pPr>
-            <a:r>
-              <a:rPr lang="en-US" sz="1050" b="1" spc="120" kern="0" dirty="0">
+            <a:off x="822960" y="2880360"/>
+            <a:ext cx="2377440" cy="914400"/>
+          </a:xfrm>
+          <a:prstGeom prst="rect">
+            <a:avLst/>
+          </a:prstGeom>
+          <a:noFill/>
+          <a:ln/>
+        </p:spPr>
+        <p:txBody>
+          <a:bodyPr wrap="square" lIns="0" tIns="0" rIns="0" bIns="0" rtlCol="0" anchor="ctr"/>
+          <a:lstStyle/>
+          <a:p>
+            <a:pPr indent="0" marL="0">
+              <a:buNone/>
+            </a:pPr>
+            <a:r>
+              <a:rPr lang="en-US" sz="1250" b="1" spc="120" kern="0" dirty="0">
                 <a:solidFill>
                   <a:srgbClr val="3730A3"/>
                 </a:solidFill>
@@ -25327,9 +25680,9 @@
                 <a:ea typeface="Calibri" pitchFamily="34" charset="-122"/>
                 <a:cs typeface="Calibri" pitchFamily="34" charset="-120"/>
               </a:rPr>
-              <a:t>MID TERM</a:t>
-            </a:r>
-            <a:endParaRPr lang="en-US" sz="1050" dirty="0"/>
+              <a:t>PRACTICALS</a:t>
+            </a:r>
+            <a:endParaRPr lang="en-US" sz="1250" dirty="0"/>
           </a:p>
         </p:txBody>
       </p:sp>
@@ -25341,27 +25694,24 @@
         </p:nvSpPr>
         <p:spPr>
           <a:xfrm>
-            <a:off x="3643884" y="2386584"/>
-            <a:ext cx="2089404" cy="548640"/>
-          </a:xfrm>
-          <a:prstGeom prst="rect">
-            <a:avLst/>
-          </a:prstGeom>
-          <a:noFill/>
-          <a:ln/>
-        </p:spPr>
-        <p:txBody>
-          <a:bodyPr wrap="square" lIns="0" tIns="0" rIns="0" bIns="0" rtlCol="0" anchor="ctr"/>
-          <a:lstStyle/>
-          <a:p>
-            <a:pPr indent="0" marL="0">
-              <a:lnSpc>
-                <a:spcPts val="2100"/>
-              </a:lnSpc>
-              <a:buNone/>
-            </a:pPr>
-            <a:r>
-              <a:rPr lang="en-US" sz="1700" b="1" dirty="0">
+            <a:off x="3108960" y="2880360"/>
+            <a:ext cx="1188720" cy="914400"/>
+          </a:xfrm>
+          <a:prstGeom prst="rect">
+            <a:avLst/>
+          </a:prstGeom>
+          <a:noFill/>
+          <a:ln/>
+        </p:spPr>
+        <p:txBody>
+          <a:bodyPr wrap="square" lIns="0" tIns="0" rIns="0" bIns="0" rtlCol="0" anchor="ctr"/>
+          <a:lstStyle/>
+          <a:p>
+            <a:pPr indent="0" marL="0">
+              <a:buNone/>
+            </a:pPr>
+            <a:r>
+              <a:rPr lang="en-US" sz="3000" b="1" dirty="0">
                 <a:solidFill>
                   <a:srgbClr val="1F2937"/>
                 </a:solidFill>
@@ -25369,9 +25719,9 @@
                 <a:ea typeface="Cambria" pitchFamily="34" charset="-122"/>
                 <a:cs typeface="Cambria" pitchFamily="34" charset="-120"/>
               </a:rPr>
-              <a:t>MTE</a:t>
-            </a:r>
-            <a:endParaRPr lang="en-US" sz="1700" dirty="0"/>
+              <a:t>45</a:t>
+            </a:r>
+            <a:endParaRPr lang="en-US" sz="3000" dirty="0"/>
           </a:p>
         </p:txBody>
       </p:sp>
@@ -25383,8 +25733,8 @@
         </p:nvSpPr>
         <p:spPr>
           <a:xfrm>
-            <a:off x="3643884" y="2953512"/>
-            <a:ext cx="2089404" cy="1188720"/>
+            <a:off x="4480560" y="2880360"/>
+            <a:ext cx="6858000" cy="914400"/>
           </a:xfrm>
           <a:prstGeom prst="rect">
             <a:avLst/>
@@ -25403,7 +25753,7 @@
               <a:buNone/>
             </a:pPr>
             <a:r>
-              <a:rPr lang="en-US" sz="1250" dirty="0">
+              <a:rPr lang="en-US" sz="1450" dirty="0">
                 <a:solidFill>
                   <a:srgbClr val="6B7280"/>
                 </a:solidFill>
@@ -25411,9 +25761,9 @@
                 <a:ea typeface="Calibri" pitchFamily="34" charset="-122"/>
                 <a:cs typeface="Calibri" pitchFamily="34" charset="-120"/>
               </a:rPr>
-              <a:t>Covers the first half of the course. Concept and judgement questions, not definition recall.</a:t>
-            </a:r>
-            <a:endParaRPr lang="en-US" sz="1250" dirty="0"/>
+              <a:t>The ten practicals, submitted and defended. This is nearly half your grade, and it is the half you build.</a:t>
+            </a:r>
+            <a:endParaRPr lang="en-US" sz="1450" dirty="0"/>
           </a:p>
         </p:txBody>
       </p:sp>
@@ -25425,12 +25775,12 @@
         </p:nvSpPr>
         <p:spPr>
           <a:xfrm>
-            <a:off x="6245352" y="1874520"/>
-            <a:ext cx="2546604" cy="2468880"/>
+            <a:off x="566928" y="3931920"/>
+            <a:ext cx="11064240" cy="914400"/>
           </a:xfrm>
           <a:prstGeom prst="roundRect">
             <a:avLst>
-              <a:gd name="adj" fmla="val 3333"/>
+              <a:gd name="adj" fmla="val 9000"/>
             </a:avLst>
           </a:prstGeom>
           <a:solidFill>
@@ -25452,24 +25802,24 @@
         </p:nvSpPr>
         <p:spPr>
           <a:xfrm>
-            <a:off x="6483096" y="2075688"/>
-            <a:ext cx="2089404" cy="256032"/>
-          </a:xfrm>
-          <a:prstGeom prst="rect">
-            <a:avLst/>
-          </a:prstGeom>
-          <a:noFill/>
-          <a:ln/>
-        </p:spPr>
-        <p:txBody>
-          <a:bodyPr wrap="square" lIns="0" tIns="0" rIns="0" bIns="0" rtlCol="0" anchor="ctr"/>
-          <a:lstStyle/>
-          <a:p>
-            <a:pPr indent="0" marL="0">
-              <a:buNone/>
-            </a:pPr>
-            <a:r>
-              <a:rPr lang="en-US" sz="1050" b="1" spc="120" kern="0" dirty="0">
+            <a:off x="822960" y="3931920"/>
+            <a:ext cx="2377440" cy="914400"/>
+          </a:xfrm>
+          <a:prstGeom prst="rect">
+            <a:avLst/>
+          </a:prstGeom>
+          <a:noFill/>
+          <a:ln/>
+        </p:spPr>
+        <p:txBody>
+          <a:bodyPr wrap="square" lIns="0" tIns="0" rIns="0" bIns="0" rtlCol="0" anchor="ctr"/>
+          <a:lstStyle/>
+          <a:p>
+            <a:pPr indent="0" marL="0">
+              <a:buNone/>
+            </a:pPr>
+            <a:r>
+              <a:rPr lang="en-US" sz="1250" b="1" spc="120" kern="0" dirty="0">
                 <a:solidFill>
                   <a:srgbClr val="A16207"/>
                 </a:solidFill>
@@ -25477,9 +25827,9 @@
                 <a:ea typeface="Calibri" pitchFamily="34" charset="-122"/>
                 <a:cs typeface="Calibri" pitchFamily="34" charset="-120"/>
               </a:rPr>
-              <a:t>END TERM</a:t>
-            </a:r>
-            <a:endParaRPr lang="en-US" sz="1050" dirty="0"/>
+              <a:t>ETP</a:t>
+            </a:r>
+            <a:endParaRPr lang="en-US" sz="1250" dirty="0"/>
           </a:p>
         </p:txBody>
       </p:sp>
@@ -25491,27 +25841,24 @@
         </p:nvSpPr>
         <p:spPr>
           <a:xfrm>
-            <a:off x="6483096" y="2386584"/>
-            <a:ext cx="2089404" cy="548640"/>
-          </a:xfrm>
-          <a:prstGeom prst="rect">
-            <a:avLst/>
-          </a:prstGeom>
-          <a:noFill/>
-          <a:ln/>
-        </p:spPr>
-        <p:txBody>
-          <a:bodyPr wrap="square" lIns="0" tIns="0" rIns="0" bIns="0" rtlCol="0" anchor="ctr"/>
-          <a:lstStyle/>
-          <a:p>
-            <a:pPr indent="0" marL="0">
-              <a:lnSpc>
-                <a:spcPts val="2100"/>
-              </a:lnSpc>
-              <a:buNone/>
-            </a:pPr>
-            <a:r>
-              <a:rPr lang="en-US" sz="1700" b="1" dirty="0">
+            <a:off x="3108960" y="3931920"/>
+            <a:ext cx="1188720" cy="914400"/>
+          </a:xfrm>
+          <a:prstGeom prst="rect">
+            <a:avLst/>
+          </a:prstGeom>
+          <a:noFill/>
+          <a:ln/>
+        </p:spPr>
+        <p:txBody>
+          <a:bodyPr wrap="square" lIns="0" tIns="0" rIns="0" bIns="0" rtlCol="0" anchor="ctr"/>
+          <a:lstStyle/>
+          <a:p>
+            <a:pPr indent="0" marL="0">
+              <a:buNone/>
+            </a:pPr>
+            <a:r>
+              <a:rPr lang="en-US" sz="3000" b="1" dirty="0">
                 <a:solidFill>
                   <a:srgbClr val="1F2937"/>
                 </a:solidFill>
@@ -25519,9 +25866,9 @@
                 <a:ea typeface="Cambria" pitchFamily="34" charset="-122"/>
                 <a:cs typeface="Cambria" pitchFamily="34" charset="-120"/>
               </a:rPr>
-              <a:t>ETE</a:t>
-            </a:r>
-            <a:endParaRPr lang="en-US" sz="1700" dirty="0"/>
+              <a:t>50</a:t>
+            </a:r>
+            <a:endParaRPr lang="en-US" sz="3000" dirty="0"/>
           </a:p>
         </p:txBody>
       </p:sp>
@@ -25533,8 +25880,8 @@
         </p:nvSpPr>
         <p:spPr>
           <a:xfrm>
-            <a:off x="6483096" y="2953512"/>
-            <a:ext cx="2089404" cy="1188720"/>
+            <a:off x="4480560" y="3931920"/>
+            <a:ext cx="6858000" cy="914400"/>
           </a:xfrm>
           <a:prstGeom prst="rect">
             <a:avLst/>
@@ -25553,7 +25900,7 @@
               <a:buNone/>
             </a:pPr>
             <a:r>
-              <a:rPr lang="en-US" sz="1250" dirty="0">
+              <a:rPr lang="en-US" sz="1450" dirty="0">
                 <a:solidFill>
                   <a:srgbClr val="6B7280"/>
                 </a:solidFill>
@@ -25561,9 +25908,9 @@
                 <a:ea typeface="Calibri" pitchFamily="34" charset="-122"/>
                 <a:cs typeface="Calibri" pitchFamily="34" charset="-120"/>
               </a:rPr>
-              <a:t>Full syllabus, with weight on the design decisions behind a system rather than framework trivia.</a:t>
-            </a:r>
-            <a:endParaRPr lang="en-US" sz="1250" dirty="0"/>
+              <a:t>End Term Practical. One assessment, half the marks, where you show the whole thing works and explain why.</a:t>
+            </a:r>
+            <a:endParaRPr lang="en-US" sz="1450" dirty="0"/>
           </a:p>
         </p:txBody>
       </p:sp>
@@ -25575,162 +25922,12 @@
         </p:nvSpPr>
         <p:spPr>
           <a:xfrm>
-            <a:off x="9084564" y="1874520"/>
-            <a:ext cx="2546604" cy="2468880"/>
+            <a:off x="566928" y="5029200"/>
+            <a:ext cx="11064240" cy="1143000"/>
           </a:xfrm>
           <a:prstGeom prst="roundRect">
             <a:avLst>
-              <a:gd name="adj" fmla="val 3333"/>
-            </a:avLst>
-          </a:prstGeom>
-          <a:solidFill>
-            <a:srgbClr val="F7F9FB"/>
-          </a:solidFill>
-          <a:ln w="12700">
-            <a:solidFill>
-              <a:srgbClr val="FFFFFF"/>
-            </a:solidFill>
-            <a:prstDash val="solid"/>
-          </a:ln>
-        </p:spPr>
-      </p:sp>
-      <p:sp>
-        <p:nvSpPr>
-          <p:cNvPr id="16" name="Text 14"/>
-          <p:cNvSpPr/>
-          <p:nvPr/>
-        </p:nvSpPr>
-        <p:spPr>
-          <a:xfrm>
-            <a:off x="9322308" y="2075688"/>
-            <a:ext cx="2089404" cy="256032"/>
-          </a:xfrm>
-          <a:prstGeom prst="rect">
-            <a:avLst/>
-          </a:prstGeom>
-          <a:noFill/>
-          <a:ln/>
-        </p:spPr>
-        <p:txBody>
-          <a:bodyPr wrap="square" lIns="0" tIns="0" rIns="0" bIns="0" rtlCol="0" anchor="ctr"/>
-          <a:lstStyle/>
-          <a:p>
-            <a:pPr indent="0" marL="0">
-              <a:buNone/>
-            </a:pPr>
-            <a:r>
-              <a:rPr lang="en-US" sz="1050" b="1" spc="120" kern="0" dirty="0">
-                <a:solidFill>
-                  <a:srgbClr val="6B7280"/>
-                </a:solidFill>
-                <a:latin typeface="Calibri" pitchFamily="34" charset="0"/>
-                <a:ea typeface="Calibri" pitchFamily="34" charset="-122"/>
-                <a:cs typeface="Calibri" pitchFamily="34" charset="-120"/>
-              </a:rPr>
-              <a:t>PRACTICALS</a:t>
-            </a:r>
-            <a:endParaRPr lang="en-US" sz="1050" dirty="0"/>
-          </a:p>
-        </p:txBody>
-      </p:sp>
-      <p:sp>
-        <p:nvSpPr>
-          <p:cNvPr id="17" name="Text 15"/>
-          <p:cNvSpPr/>
-          <p:nvPr/>
-        </p:nvSpPr>
-        <p:spPr>
-          <a:xfrm>
-            <a:off x="9322308" y="2386584"/>
-            <a:ext cx="2089404" cy="548640"/>
-          </a:xfrm>
-          <a:prstGeom prst="rect">
-            <a:avLst/>
-          </a:prstGeom>
-          <a:noFill/>
-          <a:ln/>
-        </p:spPr>
-        <p:txBody>
-          <a:bodyPr wrap="square" lIns="0" tIns="0" rIns="0" bIns="0" rtlCol="0" anchor="ctr"/>
-          <a:lstStyle/>
-          <a:p>
-            <a:pPr indent="0" marL="0">
-              <a:lnSpc>
-                <a:spcPts val="2100"/>
-              </a:lnSpc>
-              <a:buNone/>
-            </a:pPr>
-            <a:r>
-              <a:rPr lang="en-US" sz="1700" b="1" dirty="0">
-                <a:solidFill>
-                  <a:srgbClr val="1F2937"/>
-                </a:solidFill>
-                <a:latin typeface="Cambria" pitchFamily="34" charset="0"/>
-                <a:ea typeface="Cambria" pitchFamily="34" charset="-122"/>
-                <a:cs typeface="Cambria" pitchFamily="34" charset="-120"/>
-              </a:rPr>
-              <a:t>File and viva</a:t>
-            </a:r>
-            <a:endParaRPr lang="en-US" sz="1700" dirty="0"/>
-          </a:p>
-        </p:txBody>
-      </p:sp>
-      <p:sp>
-        <p:nvSpPr>
-          <p:cNvPr id="18" name="Text 16"/>
-          <p:cNvSpPr/>
-          <p:nvPr/>
-        </p:nvSpPr>
-        <p:spPr>
-          <a:xfrm>
-            <a:off x="9322308" y="2953512"/>
-            <a:ext cx="2089404" cy="1188720"/>
-          </a:xfrm>
-          <a:prstGeom prst="rect">
-            <a:avLst/>
-          </a:prstGeom>
-          <a:noFill/>
-          <a:ln/>
-        </p:spPr>
-        <p:txBody>
-          <a:bodyPr wrap="square" lIns="0" tIns="0" rIns="0" bIns="0" rtlCol="0" anchor="ctr"/>
-          <a:lstStyle/>
-          <a:p>
-            <a:pPr indent="0" marL="0">
-              <a:lnSpc>
-                <a:spcPts val="1900"/>
-              </a:lnSpc>
-              <a:buNone/>
-            </a:pPr>
-            <a:r>
-              <a:rPr lang="en-US" sz="1250" dirty="0">
-                <a:solidFill>
-                  <a:srgbClr val="6B7280"/>
-                </a:solidFill>
-                <a:latin typeface="Calibri" pitchFamily="34" charset="0"/>
-                <a:ea typeface="Calibri" pitchFamily="34" charset="-122"/>
-                <a:cs typeface="Calibri" pitchFamily="34" charset="-120"/>
-              </a:rPr>
-              <a:t>Ten practicals, submitted and defended. The viva questions come from the list you saw earlier.</a:t>
-            </a:r>
-            <a:endParaRPr lang="en-US" sz="1250" dirty="0"/>
-          </a:p>
-        </p:txBody>
-      </p:sp>
-      <p:sp>
-        <p:nvSpPr>
-          <p:cNvPr id="19" name="Shape 17"/>
-          <p:cNvSpPr/>
-          <p:nvPr/>
-        </p:nvSpPr>
-        <p:spPr>
-          <a:xfrm>
-            <a:off x="566928" y="4617720"/>
-            <a:ext cx="11064240" cy="1188720"/>
-          </a:xfrm>
-          <a:prstGeom prst="roundRect">
-            <a:avLst>
-              <a:gd name="adj" fmla="val 6923"/>
+              <a:gd name="adj" fmla="val 7200"/>
             </a:avLst>
           </a:prstGeom>
           <a:solidFill>
@@ -25746,13 +25943,13 @@
       </p:sp>
       <p:sp>
         <p:nvSpPr>
-          <p:cNvPr id="20" name="Text 18"/>
-          <p:cNvSpPr/>
-          <p:nvPr/>
-        </p:nvSpPr>
-        <p:spPr>
-          <a:xfrm>
-            <a:off x="841248" y="4800600"/>
+          <p:cNvPr id="16" name="Text 14"/>
+          <p:cNvSpPr/>
+          <p:nvPr/>
+        </p:nvSpPr>
+        <p:spPr>
+          <a:xfrm>
+            <a:off x="841248" y="5212080"/>
             <a:ext cx="2743200" cy="256032"/>
           </a:xfrm>
           <a:prstGeom prst="rect">
@@ -25785,14 +25982,14 @@
       </p:sp>
       <p:sp>
         <p:nvSpPr>
-          <p:cNvPr id="21" name="Text 19"/>
-          <p:cNvSpPr/>
-          <p:nvPr/>
-        </p:nvSpPr>
-        <p:spPr>
-          <a:xfrm>
-            <a:off x="841248" y="5093208"/>
-            <a:ext cx="10515600" cy="566928"/>
+          <p:cNvPr id="17" name="Text 15"/>
+          <p:cNvSpPr/>
+          <p:nvPr/>
+        </p:nvSpPr>
+        <p:spPr>
+          <a:xfrm>
+            <a:off x="841248" y="5504688"/>
+            <a:ext cx="10515600" cy="521208"/>
           </a:xfrm>
           <a:prstGeom prst="rect">
             <a:avLst/>
@@ -25811,7 +26008,7 @@
               <a:buNone/>
             </a:pPr>
             <a:r>
-              <a:rPr lang="en-US" sz="1500" dirty="0">
+              <a:rPr lang="en-US" sz="1400" dirty="0">
                 <a:solidFill>
                   <a:srgbClr val="1F2937"/>
                 </a:solidFill>
@@ -25819,9 +26016,9 @@
                 <a:ea typeface="Calibri" pitchFamily="34" charset="-122"/>
                 <a:cs typeface="Calibri" pitchFamily="34" charset="-120"/>
               </a:rPr>
-              <a:t>You may use AI assistance to write your code. You may not use it to replace your understanding. The viva is where that distinction becomes visible, and it becomes visible very quickly.</a:t>
-            </a:r>
-            <a:endParaRPr lang="en-US" sz="1500" dirty="0"/>
+              <a:t>You may use AI to write your code. You may not use it to replace your understanding. Notice that 95 of your 100 marks come from practicals and the end term practical, both of which you have to defend in person. That is where the difference shows, and it shows fast.</a:t>
+            </a:r>
+            <a:endParaRPr lang="en-US" sz="1400" dirty="0"/>
           </a:p>
         </p:txBody>
       </p:sp>
@@ -26204,119 +26401,135 @@
       </p:grpSpPr>
       <p:sp>
         <p:nvSpPr>
-          <p:cNvPr id="2" name="Text 0"/>
-          <p:cNvSpPr/>
-          <p:nvPr/>
-        </p:nvSpPr>
-        <p:spPr>
-          <a:xfrm>
-            <a:off x="566928" y="502920"/>
-            <a:ext cx="11064240" cy="640080"/>
-          </a:xfrm>
-          <a:prstGeom prst="rect">
-            <a:avLst/>
-          </a:prstGeom>
-          <a:noFill/>
-          <a:ln/>
-        </p:spPr>
-        <p:txBody>
-          <a:bodyPr wrap="square" lIns="0" tIns="0" rIns="0" bIns="0" rtlCol="0" anchor="ctr"/>
-          <a:lstStyle/>
-          <a:p>
-            <a:pPr indent="0" marL="0">
-              <a:buNone/>
-            </a:pPr>
-            <a:r>
-              <a:rPr lang="en-US" sz="2900" b="1" dirty="0">
-                <a:solidFill>
-                  <a:srgbClr val="1F2937"/>
+          <p:cNvPr id="2" name="Shape 0"/>
+          <p:cNvSpPr/>
+          <p:nvPr/>
+        </p:nvSpPr>
+        <p:spPr>
+          <a:xfrm>
+            <a:off x="0" y="0"/>
+            <a:ext cx="12191695" cy="6858000"/>
+          </a:xfrm>
+          <a:prstGeom prst="rect">
+            <a:avLst/>
+          </a:prstGeom>
+          <a:solidFill>
+            <a:srgbClr val="3730A3"/>
+          </a:solidFill>
+          <a:ln/>
+        </p:spPr>
+      </p:sp>
+      <p:sp>
+        <p:nvSpPr>
+          <p:cNvPr id="3" name="Shape 1"/>
+          <p:cNvSpPr/>
+          <p:nvPr/>
+        </p:nvSpPr>
+        <p:spPr>
+          <a:xfrm>
+            <a:off x="9326880" y="-1828800"/>
+            <a:ext cx="6035040" cy="6035040"/>
+          </a:xfrm>
+          <a:prstGeom prst="ellipse">
+            <a:avLst/>
+          </a:prstGeom>
+          <a:solidFill>
+            <a:srgbClr val="4B41C4"/>
+          </a:solidFill>
+          <a:ln/>
+        </p:spPr>
+      </p:sp>
+      <p:sp>
+        <p:nvSpPr>
+          <p:cNvPr id="4" name="Text 2"/>
+          <p:cNvSpPr/>
+          <p:nvPr/>
+        </p:nvSpPr>
+        <p:spPr>
+          <a:xfrm>
+            <a:off x="1005840" y="2148840"/>
+            <a:ext cx="2743200" cy="457200"/>
+          </a:xfrm>
+          <a:prstGeom prst="rect">
+            <a:avLst/>
+          </a:prstGeom>
+          <a:noFill/>
+          <a:ln/>
+        </p:spPr>
+        <p:txBody>
+          <a:bodyPr wrap="square" lIns="0" tIns="0" rIns="0" bIns="0" rtlCol="0" anchor="ctr"/>
+          <a:lstStyle/>
+          <a:p>
+            <a:pPr indent="0" marL="0">
+              <a:buNone/>
+            </a:pPr>
+            <a:r>
+              <a:rPr lang="en-US" sz="1400" b="1" spc="300" kern="0" dirty="0">
+                <a:solidFill>
+                  <a:srgbClr val="A7E8DC"/>
+                </a:solidFill>
+                <a:latin typeface="Calibri" pitchFamily="34" charset="0"/>
+                <a:ea typeface="Calibri" pitchFamily="34" charset="-122"/>
+                <a:cs typeface="Calibri" pitchFamily="34" charset="-120"/>
+              </a:rPr>
+              <a:t>SECTION 08</a:t>
+            </a:r>
+            <a:endParaRPr lang="en-US" sz="1400" dirty="0"/>
+          </a:p>
+        </p:txBody>
+      </p:sp>
+      <p:sp>
+        <p:nvSpPr>
+          <p:cNvPr id="5" name="Text 3"/>
+          <p:cNvSpPr/>
+          <p:nvPr/>
+        </p:nvSpPr>
+        <p:spPr>
+          <a:xfrm>
+            <a:off x="1005840" y="2606040"/>
+            <a:ext cx="8778240" cy="1371600"/>
+          </a:xfrm>
+          <a:prstGeom prst="rect">
+            <a:avLst/>
+          </a:prstGeom>
+          <a:noFill/>
+          <a:ln/>
+        </p:spPr>
+        <p:txBody>
+          <a:bodyPr wrap="square" lIns="0" tIns="0" rIns="0" bIns="0" rtlCol="0" anchor="ctr"/>
+          <a:lstStyle/>
+          <a:p>
+            <a:pPr indent="0" marL="0">
+              <a:lnSpc>
+                <a:spcPts val="4600"/>
+              </a:lnSpc>
+              <a:buNone/>
+            </a:pPr>
+            <a:r>
+              <a:rPr lang="en-US" sz="4000" b="1" dirty="0">
+                <a:solidFill>
+                  <a:srgbClr val="FFFFFF"/>
                 </a:solidFill>
                 <a:latin typeface="Cambria" pitchFamily="34" charset="0"/>
                 <a:ea typeface="Cambria" pitchFamily="34" charset="-122"/>
                 <a:cs typeface="Cambria" pitchFamily="34" charset="-120"/>
               </a:rPr>
-              <a:t>Where everything lives</a:t>
-            </a:r>
-            <a:endParaRPr lang="en-US" sz="2900" dirty="0"/>
-          </a:p>
-        </p:txBody>
-      </p:sp>
-      <p:sp>
-        <p:nvSpPr>
-          <p:cNvPr id="3" name="Shape 1"/>
-          <p:cNvSpPr/>
-          <p:nvPr/>
-        </p:nvSpPr>
-        <p:spPr>
-          <a:xfrm>
-            <a:off x="566928" y="1874520"/>
-            <a:ext cx="3493008" cy="2468880"/>
-          </a:xfrm>
-          <a:prstGeom prst="roundRect">
-            <a:avLst>
-              <a:gd name="adj" fmla="val 3333"/>
-            </a:avLst>
-          </a:prstGeom>
-          <a:solidFill>
-            <a:srgbClr val="E6FBF7"/>
-          </a:solidFill>
-          <a:ln w="12700">
-            <a:solidFill>
-              <a:srgbClr val="FFFFFF"/>
-            </a:solidFill>
-            <a:prstDash val="solid"/>
-          </a:ln>
-        </p:spPr>
-      </p:sp>
-      <p:sp>
-        <p:nvSpPr>
-          <p:cNvPr id="4" name="Text 2"/>
-          <p:cNvSpPr/>
-          <p:nvPr/>
-        </p:nvSpPr>
-        <p:spPr>
-          <a:xfrm>
-            <a:off x="804672" y="2075688"/>
-            <a:ext cx="3035808" cy="256032"/>
-          </a:xfrm>
-          <a:prstGeom prst="rect">
-            <a:avLst/>
-          </a:prstGeom>
-          <a:noFill/>
-          <a:ln/>
-        </p:spPr>
-        <p:txBody>
-          <a:bodyPr wrap="square" lIns="0" tIns="0" rIns="0" bIns="0" rtlCol="0" anchor="ctr"/>
-          <a:lstStyle/>
-          <a:p>
-            <a:pPr indent="0" marL="0">
-              <a:buNone/>
-            </a:pPr>
-            <a:r>
-              <a:rPr lang="en-US" sz="1050" b="1" spc="120" kern="0" dirty="0">
-                <a:solidFill>
-                  <a:srgbClr val="0F766E"/>
-                </a:solidFill>
-                <a:latin typeface="Calibri" pitchFamily="34" charset="0"/>
-                <a:ea typeface="Calibri" pitchFamily="34" charset="-122"/>
-                <a:cs typeface="Calibri" pitchFamily="34" charset="-120"/>
-              </a:rPr>
-              <a:t>CODE</a:t>
-            </a:r>
-            <a:endParaRPr lang="en-US" sz="1050" dirty="0"/>
-          </a:p>
-        </p:txBody>
-      </p:sp>
-      <p:sp>
-        <p:nvSpPr>
-          <p:cNvPr id="5" name="Text 3"/>
-          <p:cNvSpPr/>
-          <p:nvPr/>
-        </p:nvSpPr>
-        <p:spPr>
-          <a:xfrm>
-            <a:off x="804672" y="2386584"/>
-            <a:ext cx="3035808" cy="548640"/>
+              <a:t>The official bits</a:t>
+            </a:r>
+            <a:endParaRPr lang="en-US" sz="4000" dirty="0"/>
+          </a:p>
+        </p:txBody>
+      </p:sp>
+      <p:sp>
+        <p:nvSpPr>
+          <p:cNvPr id="6" name="Text 4"/>
+          <p:cNvSpPr/>
+          <p:nvPr/>
+        </p:nvSpPr>
+        <p:spPr>
+          <a:xfrm>
+            <a:off x="1005840" y="4114800"/>
+            <a:ext cx="8229600" cy="731520"/>
           </a:xfrm>
           <a:prstGeom prst="rect">
             <a:avLst/>
@@ -26330,472 +26543,22 @@
           <a:p>
             <a:pPr indent="0" marL="0">
               <a:lnSpc>
-                <a:spcPts val="2100"/>
+                <a:spcPts val="2400"/>
               </a:lnSpc>
               <a:buNone/>
             </a:pPr>
             <a:r>
-              <a:rPr lang="en-US" sz="1700" b="1" dirty="0">
-                <a:solidFill>
-                  <a:srgbClr val="1F2937"/>
-                </a:solidFill>
-                <a:latin typeface="Cambria" pitchFamily="34" charset="0"/>
-                <a:ea typeface="Cambria" pitchFamily="34" charset="-122"/>
-                <a:cs typeface="Cambria" pitchFamily="34" charset="-120"/>
-              </a:rPr>
-              <a:t>The repository</a:t>
-            </a:r>
-            <a:endParaRPr lang="en-US" sz="1700" dirty="0"/>
-          </a:p>
-        </p:txBody>
-      </p:sp>
-      <p:sp>
-        <p:nvSpPr>
-          <p:cNvPr id="6" name="Text 4"/>
-          <p:cNvSpPr/>
-          <p:nvPr/>
-        </p:nvSpPr>
-        <p:spPr>
-          <a:xfrm>
-            <a:off x="804672" y="2953512"/>
-            <a:ext cx="3035808" cy="1188720"/>
-          </a:xfrm>
-          <a:prstGeom prst="rect">
-            <a:avLst/>
-          </a:prstGeom>
-          <a:noFill/>
-          <a:ln/>
-        </p:spPr>
-        <p:txBody>
-          <a:bodyPr wrap="square" lIns="0" tIns="0" rIns="0" bIns="0" rtlCol="0" anchor="ctr"/>
-          <a:lstStyle/>
-          <a:p>
-            <a:pPr indent="0" marL="0">
-              <a:lnSpc>
-                <a:spcPts val="1900"/>
-              </a:lnSpc>
-              <a:buNone/>
-            </a:pPr>
-            <a:r>
-              <a:rPr lang="en-US" sz="1350" dirty="0">
-                <a:solidFill>
-                  <a:srgbClr val="6B7280"/>
-                </a:solidFill>
-                <a:latin typeface="Calibri" pitchFamily="34" charset="0"/>
-                <a:ea typeface="Calibri" pitchFamily="34" charset="-122"/>
-                <a:cs typeface="Calibri" pitchFamily="34" charset="-120"/>
-              </a:rPr>
-              <a:t>Every notebook, every practical, the setup script, and the requirements file. Cloned once, pulled before each session.</a:t>
-            </a:r>
-            <a:endParaRPr lang="en-US" sz="1350" dirty="0"/>
-          </a:p>
-        </p:txBody>
-      </p:sp>
-      <p:sp>
-        <p:nvSpPr>
-          <p:cNvPr id="7" name="Shape 5"/>
-          <p:cNvSpPr/>
-          <p:nvPr/>
-        </p:nvSpPr>
-        <p:spPr>
-          <a:xfrm>
-            <a:off x="4352544" y="1874520"/>
-            <a:ext cx="3493008" cy="2468880"/>
-          </a:xfrm>
-          <a:prstGeom prst="roundRect">
-            <a:avLst>
-              <a:gd name="adj" fmla="val 3333"/>
-            </a:avLst>
-          </a:prstGeom>
-          <a:solidFill>
-            <a:srgbClr val="ECEBFB"/>
-          </a:solidFill>
-          <a:ln w="12700">
-            <a:solidFill>
-              <a:srgbClr val="FFFFFF"/>
-            </a:solidFill>
-            <a:prstDash val="solid"/>
-          </a:ln>
-        </p:spPr>
-      </p:sp>
-      <p:sp>
-        <p:nvSpPr>
-          <p:cNvPr id="8" name="Text 6"/>
-          <p:cNvSpPr/>
-          <p:nvPr/>
-        </p:nvSpPr>
-        <p:spPr>
-          <a:xfrm>
-            <a:off x="4590288" y="2075688"/>
-            <a:ext cx="3035808" cy="256032"/>
-          </a:xfrm>
-          <a:prstGeom prst="rect">
-            <a:avLst/>
-          </a:prstGeom>
-          <a:noFill/>
-          <a:ln/>
-        </p:spPr>
-        <p:txBody>
-          <a:bodyPr wrap="square" lIns="0" tIns="0" rIns="0" bIns="0" rtlCol="0" anchor="ctr"/>
-          <a:lstStyle/>
-          <a:p>
-            <a:pPr indent="0" marL="0">
-              <a:buNone/>
-            </a:pPr>
-            <a:r>
-              <a:rPr lang="en-US" sz="1050" b="1" spc="120" kern="0" dirty="0">
-                <a:solidFill>
-                  <a:srgbClr val="3730A3"/>
-                </a:solidFill>
-                <a:latin typeface="Calibri" pitchFamily="34" charset="0"/>
-                <a:ea typeface="Calibri" pitchFamily="34" charset="-122"/>
-                <a:cs typeface="Calibri" pitchFamily="34" charset="-120"/>
-              </a:rPr>
-              <a:t>SLIDES</a:t>
-            </a:r>
-            <a:endParaRPr lang="en-US" sz="1050" dirty="0"/>
-          </a:p>
-        </p:txBody>
-      </p:sp>
-      <p:sp>
-        <p:nvSpPr>
-          <p:cNvPr id="9" name="Text 7"/>
-          <p:cNvSpPr/>
-          <p:nvPr/>
-        </p:nvSpPr>
-        <p:spPr>
-          <a:xfrm>
-            <a:off x="4590288" y="2386584"/>
-            <a:ext cx="3035808" cy="548640"/>
-          </a:xfrm>
-          <a:prstGeom prst="rect">
-            <a:avLst/>
-          </a:prstGeom>
-          <a:noFill/>
-          <a:ln/>
-        </p:spPr>
-        <p:txBody>
-          <a:bodyPr wrap="square" lIns="0" tIns="0" rIns="0" bIns="0" rtlCol="0" anchor="ctr"/>
-          <a:lstStyle/>
-          <a:p>
-            <a:pPr indent="0" marL="0">
-              <a:lnSpc>
-                <a:spcPts val="2100"/>
-              </a:lnSpc>
-              <a:buNone/>
-            </a:pPr>
-            <a:r>
-              <a:rPr lang="en-US" sz="1700" b="1" dirty="0">
-                <a:solidFill>
-                  <a:srgbClr val="1F2937"/>
-                </a:solidFill>
-                <a:latin typeface="Cambria" pitchFamily="34" charset="0"/>
-                <a:ea typeface="Cambria" pitchFamily="34" charset="-122"/>
-                <a:cs typeface="Cambria" pitchFamily="34" charset="-120"/>
-              </a:rPr>
-              <a:t>Decks and handouts</a:t>
-            </a:r>
-            <a:endParaRPr lang="en-US" sz="1700" dirty="0"/>
-          </a:p>
-        </p:txBody>
-      </p:sp>
-      <p:sp>
-        <p:nvSpPr>
-          <p:cNvPr id="10" name="Text 8"/>
-          <p:cNvSpPr/>
-          <p:nvPr/>
-        </p:nvSpPr>
-        <p:spPr>
-          <a:xfrm>
-            <a:off x="4590288" y="2953512"/>
-            <a:ext cx="3035808" cy="1188720"/>
-          </a:xfrm>
-          <a:prstGeom prst="rect">
-            <a:avLst/>
-          </a:prstGeom>
-          <a:noFill/>
-          <a:ln/>
-        </p:spPr>
-        <p:txBody>
-          <a:bodyPr wrap="square" lIns="0" tIns="0" rIns="0" bIns="0" rtlCol="0" anchor="ctr"/>
-          <a:lstStyle/>
-          <a:p>
-            <a:pPr indent="0" marL="0">
-              <a:lnSpc>
-                <a:spcPts val="1900"/>
-              </a:lnSpc>
-              <a:buNone/>
-            </a:pPr>
-            <a:r>
-              <a:rPr lang="en-US" sz="1350" dirty="0">
-                <a:solidFill>
-                  <a:srgbClr val="6B7280"/>
-                </a:solidFill>
-                <a:latin typeface="Calibri" pitchFamily="34" charset="0"/>
-                <a:ea typeface="Calibri" pitchFamily="34" charset="-122"/>
-                <a:cs typeface="Calibri" pitchFamily="34" charset="-120"/>
-              </a:rPr>
-              <a:t>Each session ships a deck and a collapsed handout you can read without the slides.</a:t>
-            </a:r>
-            <a:endParaRPr lang="en-US" sz="1350" dirty="0"/>
-          </a:p>
-        </p:txBody>
-      </p:sp>
-      <p:sp>
-        <p:nvSpPr>
-          <p:cNvPr id="11" name="Shape 9"/>
-          <p:cNvSpPr/>
-          <p:nvPr/>
-        </p:nvSpPr>
-        <p:spPr>
-          <a:xfrm>
-            <a:off x="8138160" y="1874520"/>
-            <a:ext cx="3493008" cy="2468880"/>
-          </a:xfrm>
-          <a:prstGeom prst="roundRect">
-            <a:avLst>
-              <a:gd name="adj" fmla="val 3333"/>
-            </a:avLst>
-          </a:prstGeom>
-          <a:solidFill>
-            <a:srgbClr val="FEF6E0"/>
-          </a:solidFill>
-          <a:ln w="12700">
-            <a:solidFill>
-              <a:srgbClr val="FFFFFF"/>
-            </a:solidFill>
-            <a:prstDash val="solid"/>
-          </a:ln>
-        </p:spPr>
-      </p:sp>
-      <p:sp>
-        <p:nvSpPr>
-          <p:cNvPr id="12" name="Text 10"/>
-          <p:cNvSpPr/>
-          <p:nvPr/>
-        </p:nvSpPr>
-        <p:spPr>
-          <a:xfrm>
-            <a:off x="8375904" y="2075688"/>
-            <a:ext cx="3035808" cy="256032"/>
-          </a:xfrm>
-          <a:prstGeom prst="rect">
-            <a:avLst/>
-          </a:prstGeom>
-          <a:noFill/>
-          <a:ln/>
-        </p:spPr>
-        <p:txBody>
-          <a:bodyPr wrap="square" lIns="0" tIns="0" rIns="0" bIns="0" rtlCol="0" anchor="ctr"/>
-          <a:lstStyle/>
-          <a:p>
-            <a:pPr indent="0" marL="0">
-              <a:buNone/>
-            </a:pPr>
-            <a:r>
-              <a:rPr lang="en-US" sz="1050" b="1" spc="120" kern="0" dirty="0">
-                <a:solidFill>
-                  <a:srgbClr val="A16207"/>
-                </a:solidFill>
-                <a:latin typeface="Calibri" pitchFamily="34" charset="0"/>
-                <a:ea typeface="Calibri" pitchFamily="34" charset="-122"/>
-                <a:cs typeface="Calibri" pitchFamily="34" charset="-120"/>
-              </a:rPr>
-              <a:t>HELP</a:t>
-            </a:r>
-            <a:endParaRPr lang="en-US" sz="1050" dirty="0"/>
-          </a:p>
-        </p:txBody>
-      </p:sp>
-      <p:sp>
-        <p:nvSpPr>
-          <p:cNvPr id="13" name="Text 11"/>
-          <p:cNvSpPr/>
-          <p:nvPr/>
-        </p:nvSpPr>
-        <p:spPr>
-          <a:xfrm>
-            <a:off x="8375904" y="2386584"/>
-            <a:ext cx="3035808" cy="548640"/>
-          </a:xfrm>
-          <a:prstGeom prst="rect">
-            <a:avLst/>
-          </a:prstGeom>
-          <a:noFill/>
-          <a:ln/>
-        </p:spPr>
-        <p:txBody>
-          <a:bodyPr wrap="square" lIns="0" tIns="0" rIns="0" bIns="0" rtlCol="0" anchor="ctr"/>
-          <a:lstStyle/>
-          <a:p>
-            <a:pPr indent="0" marL="0">
-              <a:lnSpc>
-                <a:spcPts val="2100"/>
-              </a:lnSpc>
-              <a:buNone/>
-            </a:pPr>
-            <a:r>
-              <a:rPr lang="en-US" sz="1700" b="1" dirty="0">
-                <a:solidFill>
-                  <a:srgbClr val="1F2937"/>
-                </a:solidFill>
-                <a:latin typeface="Cambria" pitchFamily="34" charset="0"/>
-                <a:ea typeface="Cambria" pitchFamily="34" charset="-122"/>
-                <a:cs typeface="Cambria" pitchFamily="34" charset="-120"/>
-              </a:rPr>
-              <a:t>The course channel</a:t>
-            </a:r>
-            <a:endParaRPr lang="en-US" sz="1700" dirty="0"/>
-          </a:p>
-        </p:txBody>
-      </p:sp>
-      <p:sp>
-        <p:nvSpPr>
-          <p:cNvPr id="14" name="Text 12"/>
-          <p:cNvSpPr/>
-          <p:nvPr/>
-        </p:nvSpPr>
-        <p:spPr>
-          <a:xfrm>
-            <a:off x="8375904" y="2953512"/>
-            <a:ext cx="3035808" cy="1188720"/>
-          </a:xfrm>
-          <a:prstGeom prst="rect">
-            <a:avLst/>
-          </a:prstGeom>
-          <a:noFill/>
-          <a:ln/>
-        </p:spPr>
-        <p:txBody>
-          <a:bodyPr wrap="square" lIns="0" tIns="0" rIns="0" bIns="0" rtlCol="0" anchor="ctr"/>
-          <a:lstStyle/>
-          <a:p>
-            <a:pPr indent="0" marL="0">
-              <a:lnSpc>
-                <a:spcPts val="1900"/>
-              </a:lnSpc>
-              <a:buNone/>
-            </a:pPr>
-            <a:r>
-              <a:rPr lang="en-US" sz="1350" dirty="0">
-                <a:solidFill>
-                  <a:srgbClr val="6B7280"/>
-                </a:solidFill>
-                <a:latin typeface="Calibri" pitchFamily="34" charset="0"/>
-                <a:ea typeface="Calibri" pitchFamily="34" charset="-122"/>
-                <a:cs typeface="Calibri" pitchFamily="34" charset="-120"/>
-              </a:rPr>
-              <a:t>Post the exact error, not "it is not working". Screenshot the full traceback. Somebody will have hit it already.</a:t>
-            </a:r>
-            <a:endParaRPr lang="en-US" sz="1350" dirty="0"/>
-          </a:p>
-        </p:txBody>
-      </p:sp>
-      <p:sp>
-        <p:nvSpPr>
-          <p:cNvPr id="15" name="Shape 13"/>
-          <p:cNvSpPr/>
-          <p:nvPr/>
-        </p:nvSpPr>
-        <p:spPr>
-          <a:xfrm>
-            <a:off x="566928" y="4617720"/>
-            <a:ext cx="11064240" cy="1005840"/>
-          </a:xfrm>
-          <a:prstGeom prst="roundRect">
-            <a:avLst>
-              <a:gd name="adj" fmla="val 8182"/>
-            </a:avLst>
-          </a:prstGeom>
-          <a:solidFill>
-            <a:srgbClr val="E6FBF7"/>
-          </a:solidFill>
-          <a:ln w="12700">
-            <a:solidFill>
-              <a:srgbClr val="FFFFFF"/>
-            </a:solidFill>
-            <a:prstDash val="solid"/>
-          </a:ln>
-        </p:spPr>
-      </p:sp>
-      <p:sp>
-        <p:nvSpPr>
-          <p:cNvPr id="16" name="Text 14"/>
-          <p:cNvSpPr/>
-          <p:nvPr/>
-        </p:nvSpPr>
-        <p:spPr>
-          <a:xfrm>
-            <a:off x="841248" y="4800600"/>
-            <a:ext cx="3657600" cy="256032"/>
-          </a:xfrm>
-          <a:prstGeom prst="rect">
-            <a:avLst/>
-          </a:prstGeom>
-          <a:noFill/>
-          <a:ln/>
-        </p:spPr>
-        <p:txBody>
-          <a:bodyPr wrap="square" lIns="0" tIns="0" rIns="0" bIns="0" rtlCol="0" anchor="ctr"/>
-          <a:lstStyle/>
-          <a:p>
-            <a:pPr indent="0" marL="0">
-              <a:buNone/>
-            </a:pPr>
-            <a:r>
-              <a:rPr lang="en-US" sz="1050" b="1" spc="130" kern="0" dirty="0">
-                <a:solidFill>
-                  <a:srgbClr val="0F766E"/>
-                </a:solidFill>
-                <a:latin typeface="Calibri" pitchFamily="34" charset="0"/>
-                <a:ea typeface="Calibri" pitchFamily="34" charset="-122"/>
-                <a:cs typeface="Calibri" pitchFamily="34" charset="-120"/>
-              </a:rPr>
-              <a:t>RIGHT NOW, BEFORE YOU LEAVE</a:t>
-            </a:r>
-            <a:endParaRPr lang="en-US" sz="1050" dirty="0"/>
-          </a:p>
-        </p:txBody>
-      </p:sp>
-      <p:sp>
-        <p:nvSpPr>
-          <p:cNvPr id="17" name="Text 15"/>
-          <p:cNvSpPr/>
-          <p:nvPr/>
-        </p:nvSpPr>
-        <p:spPr>
-          <a:xfrm>
-            <a:off x="841248" y="5093208"/>
-            <a:ext cx="10515600" cy="384048"/>
-          </a:xfrm>
-          <a:prstGeom prst="rect">
-            <a:avLst/>
-          </a:prstGeom>
-          <a:noFill/>
-          <a:ln/>
-        </p:spPr>
-        <p:txBody>
-          <a:bodyPr wrap="square" lIns="0" tIns="0" rIns="0" bIns="0" rtlCol="0" anchor="ctr"/>
-          <a:lstStyle/>
-          <a:p>
-            <a:pPr indent="0" marL="0">
-              <a:lnSpc>
-                <a:spcPts val="2100"/>
-              </a:lnSpc>
-              <a:buNone/>
-            </a:pPr>
-            <a:r>
-              <a:rPr lang="en-US" sz="1500" dirty="0">
-                <a:solidFill>
-                  <a:srgbClr val="1F2937"/>
-                </a:solidFill>
-                <a:latin typeface="Calibri" pitchFamily="34" charset="0"/>
-                <a:ea typeface="Calibri" pitchFamily="34" charset="-122"/>
-                <a:cs typeface="Calibri" pitchFamily="34" charset="-120"/>
-              </a:rPr>
-              <a:t>Take out your phone and note the repository link on the next slide. Do the clone tonight, not on the morning of the first practical.</a:t>
-            </a:r>
-            <a:endParaRPr lang="en-US" sz="1500" dirty="0"/>
+              <a:rPr lang="en-US" sz="1600" dirty="0">
+                <a:solidFill>
+                  <a:srgbClr val="B9B5EA"/>
+                </a:solidFill>
+                <a:latin typeface="Calibri" pitchFamily="34" charset="0"/>
+                <a:ea typeface="Calibri" pitchFamily="34" charset="-122"/>
+                <a:cs typeface="Calibri" pitchFamily="34" charset="-120"/>
+              </a:rPr>
+              <a:t>The formal record. Credits, outcomes, textbooks, and the assessment schedule.</a:t>
+            </a:r>
+            <a:endParaRPr lang="en-US" sz="1600" dirty="0"/>
           </a:p>
         </p:txBody>
       </p:sp>
@@ -27540,24 +27303,63 @@
         </p:nvSpPr>
         <p:spPr>
           <a:xfrm>
-            <a:off x="566928" y="502920"/>
-            <a:ext cx="11064240" cy="640080"/>
-          </a:xfrm>
-          <a:prstGeom prst="rect">
-            <a:avLst/>
-          </a:prstGeom>
-          <a:noFill/>
-          <a:ln/>
-        </p:spPr>
-        <p:txBody>
-          <a:bodyPr wrap="square" lIns="0" tIns="0" rIns="0" bIns="0" rtlCol="0" anchor="ctr"/>
-          <a:lstStyle/>
-          <a:p>
-            <a:pPr indent="0" marL="0">
-              <a:buNone/>
-            </a:pPr>
-            <a:r>
-              <a:rPr lang="en-US" sz="2900" b="1" dirty="0">
+            <a:off x="566928" y="384048"/>
+            <a:ext cx="10058400" cy="274320"/>
+          </a:xfrm>
+          <a:prstGeom prst="rect">
+            <a:avLst/>
+          </a:prstGeom>
+          <a:noFill/>
+          <a:ln/>
+        </p:spPr>
+        <p:txBody>
+          <a:bodyPr wrap="square" lIns="0" tIns="0" rIns="0" bIns="0" rtlCol="0" anchor="ctr"/>
+          <a:lstStyle/>
+          <a:p>
+            <a:pPr indent="0" marL="0">
+              <a:buNone/>
+            </a:pPr>
+            <a:r>
+              <a:rPr lang="en-US" sz="1150" b="1" spc="140" kern="0" dirty="0">
+                <a:solidFill>
+                  <a:srgbClr val="0F766E"/>
+                </a:solidFill>
+                <a:latin typeface="Calibri" pitchFamily="34" charset="0"/>
+                <a:ea typeface="Calibri" pitchFamily="34" charset="-122"/>
+                <a:cs typeface="Calibri" pitchFamily="34" charset="-120"/>
+              </a:rPr>
+              <a:t>THE FORMAL DETAILS</a:t>
+            </a:r>
+            <a:endParaRPr lang="en-US" sz="1150" dirty="0"/>
+          </a:p>
+        </p:txBody>
+      </p:sp>
+      <p:sp>
+        <p:nvSpPr>
+          <p:cNvPr id="3" name="Text 1"/>
+          <p:cNvSpPr/>
+          <p:nvPr/>
+        </p:nvSpPr>
+        <p:spPr>
+          <a:xfrm>
+            <a:off x="566928" y="694944"/>
+            <a:ext cx="11064240" cy="566928"/>
+          </a:xfrm>
+          <a:prstGeom prst="rect">
+            <a:avLst/>
+          </a:prstGeom>
+          <a:noFill/>
+          <a:ln/>
+        </p:spPr>
+        <p:txBody>
+          <a:bodyPr wrap="square" lIns="0" tIns="0" rIns="0" bIns="0" rtlCol="0" anchor="ctr"/>
+          <a:lstStyle/>
+          <a:p>
+            <a:pPr indent="0" marL="0">
+              <a:buNone/>
+            </a:pPr>
+            <a:r>
+              <a:rPr lang="en-US" sz="2700" b="1" dirty="0">
                 <a:solidFill>
                   <a:srgbClr val="1F2937"/>
                 </a:solidFill>
@@ -27565,51 +27367,9 @@
                 <a:ea typeface="Cambria" pitchFamily="34" charset="-122"/>
                 <a:cs typeface="Cambria" pitchFamily="34" charset="-120"/>
               </a:rPr>
-              <a:t>What you will be able to say in December</a:t>
-            </a:r>
-            <a:endParaRPr lang="en-US" sz="2900" dirty="0"/>
-          </a:p>
-        </p:txBody>
-      </p:sp>
-      <p:sp>
-        <p:nvSpPr>
-          <p:cNvPr id="3" name="Text 1"/>
-          <p:cNvSpPr/>
-          <p:nvPr/>
-        </p:nvSpPr>
-        <p:spPr>
-          <a:xfrm>
-            <a:off x="566928" y="1554480"/>
-            <a:ext cx="10607040" cy="457200"/>
-          </a:xfrm>
-          <a:prstGeom prst="rect">
-            <a:avLst/>
-          </a:prstGeom>
-          <a:noFill/>
-          <a:ln/>
-        </p:spPr>
-        <p:txBody>
-          <a:bodyPr wrap="square" lIns="0" tIns="0" rIns="0" bIns="0" rtlCol="0" anchor="ctr"/>
-          <a:lstStyle/>
-          <a:p>
-            <a:pPr algn="l" indent="0" marL="0">
-              <a:lnSpc>
-                <a:spcPts val="2700"/>
-              </a:lnSpc>
-              <a:buNone/>
-            </a:pPr>
-            <a:r>
-              <a:rPr lang="en-US" sz="1700" dirty="0">
-                <a:solidFill>
-                  <a:srgbClr val="6B7280"/>
-                </a:solidFill>
-                <a:latin typeface="Calibri" pitchFamily="34" charset="0"/>
-                <a:ea typeface="Calibri" pitchFamily="34" charset="-122"/>
-                <a:cs typeface="Calibri" pitchFamily="34" charset="-120"/>
-              </a:rPr>
-              <a:t>Not "I did a course on AI agents." Anybody can say that.</a:t>
-            </a:r>
-            <a:endParaRPr lang="en-US" sz="1700" dirty="0"/>
+              <a:t>Course at a glance</a:t>
+            </a:r>
+            <a:endParaRPr lang="en-US" sz="2700" dirty="0"/>
           </a:p>
         </p:txBody>
       </p:sp>
@@ -27621,12 +27381,12 @@
         </p:nvSpPr>
         <p:spPr>
           <a:xfrm>
-            <a:off x="566928" y="2194560"/>
-            <a:ext cx="11064240" cy="2286000"/>
+            <a:off x="566928" y="1691640"/>
+            <a:ext cx="11064240" cy="548640"/>
           </a:xfrm>
           <a:prstGeom prst="roundRect">
             <a:avLst>
-              <a:gd name="adj" fmla="val 4800"/>
+              <a:gd name="adj" fmla="val 11667"/>
             </a:avLst>
           </a:prstGeom>
           <a:solidFill>
@@ -27648,8 +27408,467 @@
         </p:nvSpPr>
         <p:spPr>
           <a:xfrm>
-            <a:off x="1051560" y="2194560"/>
-            <a:ext cx="10104120" cy="2286000"/>
+            <a:off x="822960" y="1691640"/>
+            <a:ext cx="2377440" cy="548640"/>
+          </a:xfrm>
+          <a:prstGeom prst="rect">
+            <a:avLst/>
+          </a:prstGeom>
+          <a:noFill/>
+          <a:ln/>
+        </p:spPr>
+        <p:txBody>
+          <a:bodyPr wrap="square" lIns="0" tIns="0" rIns="0" bIns="0" rtlCol="0" anchor="ctr"/>
+          <a:lstStyle/>
+          <a:p>
+            <a:pPr indent="0" marL="0">
+              <a:buNone/>
+            </a:pPr>
+            <a:r>
+              <a:rPr lang="en-US" sz="1200" b="1" spc="120" kern="0" dirty="0">
+                <a:solidFill>
+                  <a:srgbClr val="0F766E"/>
+                </a:solidFill>
+                <a:latin typeface="Calibri" pitchFamily="34" charset="0"/>
+                <a:ea typeface="Calibri" pitchFamily="34" charset="-122"/>
+                <a:cs typeface="Calibri" pitchFamily="34" charset="-120"/>
+              </a:rPr>
+              <a:t>CODE</a:t>
+            </a:r>
+            <a:endParaRPr lang="en-US" sz="1200" dirty="0"/>
+          </a:p>
+        </p:txBody>
+      </p:sp>
+      <p:sp>
+        <p:nvSpPr>
+          <p:cNvPr id="6" name="Text 4"/>
+          <p:cNvSpPr/>
+          <p:nvPr/>
+        </p:nvSpPr>
+        <p:spPr>
+          <a:xfrm>
+            <a:off x="3291840" y="1691640"/>
+            <a:ext cx="8046720" cy="548640"/>
+          </a:xfrm>
+          <a:prstGeom prst="rect">
+            <a:avLst/>
+          </a:prstGeom>
+          <a:noFill/>
+          <a:ln/>
+        </p:spPr>
+        <p:txBody>
+          <a:bodyPr wrap="square" lIns="0" tIns="0" rIns="0" bIns="0" rtlCol="0" anchor="ctr"/>
+          <a:lstStyle/>
+          <a:p>
+            <a:pPr indent="0" marL="0">
+              <a:buNone/>
+            </a:pPr>
+            <a:r>
+              <a:rPr lang="en-US" sz="1500" dirty="0">
+                <a:solidFill>
+                  <a:srgbClr val="1F2937"/>
+                </a:solidFill>
+                <a:latin typeface="Calibri" pitchFamily="34" charset="0"/>
+                <a:ea typeface="Calibri" pitchFamily="34" charset="-122"/>
+                <a:cs typeface="Calibri" pitchFamily="34" charset="-120"/>
+              </a:rPr>
+              <a:t>CSE476</a:t>
+            </a:r>
+            <a:endParaRPr lang="en-US" sz="1500" dirty="0"/>
+          </a:p>
+        </p:txBody>
+      </p:sp>
+      <p:sp>
+        <p:nvSpPr>
+          <p:cNvPr id="7" name="Shape 5"/>
+          <p:cNvSpPr/>
+          <p:nvPr/>
+        </p:nvSpPr>
+        <p:spPr>
+          <a:xfrm>
+            <a:off x="566928" y="2350008"/>
+            <a:ext cx="11064240" cy="548640"/>
+          </a:xfrm>
+          <a:prstGeom prst="roundRect">
+            <a:avLst>
+              <a:gd name="adj" fmla="val 11667"/>
+            </a:avLst>
+          </a:prstGeom>
+          <a:solidFill>
+            <a:srgbClr val="F7F9FB"/>
+          </a:solidFill>
+          <a:ln w="12700">
+            <a:solidFill>
+              <a:srgbClr val="FFFFFF"/>
+            </a:solidFill>
+            <a:prstDash val="solid"/>
+          </a:ln>
+        </p:spPr>
+      </p:sp>
+      <p:sp>
+        <p:nvSpPr>
+          <p:cNvPr id="8" name="Text 6"/>
+          <p:cNvSpPr/>
+          <p:nvPr/>
+        </p:nvSpPr>
+        <p:spPr>
+          <a:xfrm>
+            <a:off x="822960" y="2350008"/>
+            <a:ext cx="2377440" cy="548640"/>
+          </a:xfrm>
+          <a:prstGeom prst="rect">
+            <a:avLst/>
+          </a:prstGeom>
+          <a:noFill/>
+          <a:ln/>
+        </p:spPr>
+        <p:txBody>
+          <a:bodyPr wrap="square" lIns="0" tIns="0" rIns="0" bIns="0" rtlCol="0" anchor="ctr"/>
+          <a:lstStyle/>
+          <a:p>
+            <a:pPr indent="0" marL="0">
+              <a:buNone/>
+            </a:pPr>
+            <a:r>
+              <a:rPr lang="en-US" sz="1200" b="1" spc="120" kern="0" dirty="0">
+                <a:solidFill>
+                  <a:srgbClr val="6B7280"/>
+                </a:solidFill>
+                <a:latin typeface="Calibri" pitchFamily="34" charset="0"/>
+                <a:ea typeface="Calibri" pitchFamily="34" charset="-122"/>
+                <a:cs typeface="Calibri" pitchFamily="34" charset="-120"/>
+              </a:rPr>
+              <a:t>STRUCTURE</a:t>
+            </a:r>
+            <a:endParaRPr lang="en-US" sz="1200" dirty="0"/>
+          </a:p>
+        </p:txBody>
+      </p:sp>
+      <p:sp>
+        <p:nvSpPr>
+          <p:cNvPr id="9" name="Text 7"/>
+          <p:cNvSpPr/>
+          <p:nvPr/>
+        </p:nvSpPr>
+        <p:spPr>
+          <a:xfrm>
+            <a:off x="3291840" y="2350008"/>
+            <a:ext cx="8046720" cy="548640"/>
+          </a:xfrm>
+          <a:prstGeom prst="rect">
+            <a:avLst/>
+          </a:prstGeom>
+          <a:noFill/>
+          <a:ln/>
+        </p:spPr>
+        <p:txBody>
+          <a:bodyPr wrap="square" lIns="0" tIns="0" rIns="0" bIns="0" rtlCol="0" anchor="ctr"/>
+          <a:lstStyle/>
+          <a:p>
+            <a:pPr indent="0" marL="0">
+              <a:buNone/>
+            </a:pPr>
+            <a:r>
+              <a:rPr lang="en-US" sz="1500" dirty="0">
+                <a:solidFill>
+                  <a:srgbClr val="1F2937"/>
+                </a:solidFill>
+                <a:latin typeface="Calibri" pitchFamily="34" charset="0"/>
+                <a:ea typeface="Calibri" pitchFamily="34" charset="-122"/>
+                <a:cs typeface="Calibri" pitchFamily="34" charset="-120"/>
+              </a:rPr>
+              <a:t>Lecture 3, Tutorial 0, Practical 1</a:t>
+            </a:r>
+            <a:endParaRPr lang="en-US" sz="1500" dirty="0"/>
+          </a:p>
+        </p:txBody>
+      </p:sp>
+      <p:sp>
+        <p:nvSpPr>
+          <p:cNvPr id="10" name="Shape 8"/>
+          <p:cNvSpPr/>
+          <p:nvPr/>
+        </p:nvSpPr>
+        <p:spPr>
+          <a:xfrm>
+            <a:off x="566928" y="3008376"/>
+            <a:ext cx="11064240" cy="548640"/>
+          </a:xfrm>
+          <a:prstGeom prst="roundRect">
+            <a:avLst>
+              <a:gd name="adj" fmla="val 11667"/>
+            </a:avLst>
+          </a:prstGeom>
+          <a:solidFill>
+            <a:srgbClr val="E6FBF7"/>
+          </a:solidFill>
+          <a:ln w="12700">
+            <a:solidFill>
+              <a:srgbClr val="FFFFFF"/>
+            </a:solidFill>
+            <a:prstDash val="solid"/>
+          </a:ln>
+        </p:spPr>
+      </p:sp>
+      <p:sp>
+        <p:nvSpPr>
+          <p:cNvPr id="11" name="Text 9"/>
+          <p:cNvSpPr/>
+          <p:nvPr/>
+        </p:nvSpPr>
+        <p:spPr>
+          <a:xfrm>
+            <a:off x="822960" y="3008376"/>
+            <a:ext cx="2377440" cy="548640"/>
+          </a:xfrm>
+          <a:prstGeom prst="rect">
+            <a:avLst/>
+          </a:prstGeom>
+          <a:noFill/>
+          <a:ln/>
+        </p:spPr>
+        <p:txBody>
+          <a:bodyPr wrap="square" lIns="0" tIns="0" rIns="0" bIns="0" rtlCol="0" anchor="ctr"/>
+          <a:lstStyle/>
+          <a:p>
+            <a:pPr indent="0" marL="0">
+              <a:buNone/>
+            </a:pPr>
+            <a:r>
+              <a:rPr lang="en-US" sz="1200" b="1" spc="120" kern="0" dirty="0">
+                <a:solidFill>
+                  <a:srgbClr val="0F766E"/>
+                </a:solidFill>
+                <a:latin typeface="Calibri" pitchFamily="34" charset="0"/>
+                <a:ea typeface="Calibri" pitchFamily="34" charset="-122"/>
+                <a:cs typeface="Calibri" pitchFamily="34" charset="-120"/>
+              </a:rPr>
+              <a:t>CREDITS</a:t>
+            </a:r>
+            <a:endParaRPr lang="en-US" sz="1200" dirty="0"/>
+          </a:p>
+        </p:txBody>
+      </p:sp>
+      <p:sp>
+        <p:nvSpPr>
+          <p:cNvPr id="12" name="Text 10"/>
+          <p:cNvSpPr/>
+          <p:nvPr/>
+        </p:nvSpPr>
+        <p:spPr>
+          <a:xfrm>
+            <a:off x="3291840" y="3008376"/>
+            <a:ext cx="8046720" cy="548640"/>
+          </a:xfrm>
+          <a:prstGeom prst="rect">
+            <a:avLst/>
+          </a:prstGeom>
+          <a:noFill/>
+          <a:ln/>
+        </p:spPr>
+        <p:txBody>
+          <a:bodyPr wrap="square" lIns="0" tIns="0" rIns="0" bIns="0" rtlCol="0" anchor="ctr"/>
+          <a:lstStyle/>
+          <a:p>
+            <a:pPr indent="0" marL="0">
+              <a:buNone/>
+            </a:pPr>
+            <a:r>
+              <a:rPr lang="en-US" sz="1500" dirty="0">
+                <a:solidFill>
+                  <a:srgbClr val="1F2937"/>
+                </a:solidFill>
+                <a:latin typeface="Calibri" pitchFamily="34" charset="0"/>
+                <a:ea typeface="Calibri" pitchFamily="34" charset="-122"/>
+                <a:cs typeface="Calibri" pitchFamily="34" charset="-120"/>
+              </a:rPr>
+              <a:t>4.0</a:t>
+            </a:r>
+            <a:endParaRPr lang="en-US" sz="1500" dirty="0"/>
+          </a:p>
+        </p:txBody>
+      </p:sp>
+      <p:sp>
+        <p:nvSpPr>
+          <p:cNvPr id="13" name="Shape 11"/>
+          <p:cNvSpPr/>
+          <p:nvPr/>
+        </p:nvSpPr>
+        <p:spPr>
+          <a:xfrm>
+            <a:off x="566928" y="3666744"/>
+            <a:ext cx="11064240" cy="548640"/>
+          </a:xfrm>
+          <a:prstGeom prst="roundRect">
+            <a:avLst>
+              <a:gd name="adj" fmla="val 11667"/>
+            </a:avLst>
+          </a:prstGeom>
+          <a:solidFill>
+            <a:srgbClr val="F7F9FB"/>
+          </a:solidFill>
+          <a:ln w="12700">
+            <a:solidFill>
+              <a:srgbClr val="FFFFFF"/>
+            </a:solidFill>
+            <a:prstDash val="solid"/>
+          </a:ln>
+        </p:spPr>
+      </p:sp>
+      <p:sp>
+        <p:nvSpPr>
+          <p:cNvPr id="14" name="Text 12"/>
+          <p:cNvSpPr/>
+          <p:nvPr/>
+        </p:nvSpPr>
+        <p:spPr>
+          <a:xfrm>
+            <a:off x="822960" y="3666744"/>
+            <a:ext cx="2377440" cy="548640"/>
+          </a:xfrm>
+          <a:prstGeom prst="rect">
+            <a:avLst/>
+          </a:prstGeom>
+          <a:noFill/>
+          <a:ln/>
+        </p:spPr>
+        <p:txBody>
+          <a:bodyPr wrap="square" lIns="0" tIns="0" rIns="0" bIns="0" rtlCol="0" anchor="ctr"/>
+          <a:lstStyle/>
+          <a:p>
+            <a:pPr indent="0" marL="0">
+              <a:buNone/>
+            </a:pPr>
+            <a:r>
+              <a:rPr lang="en-US" sz="1200" b="1" spc="120" kern="0" dirty="0">
+                <a:solidFill>
+                  <a:srgbClr val="6B7280"/>
+                </a:solidFill>
+                <a:latin typeface="Calibri" pitchFamily="34" charset="0"/>
+                <a:ea typeface="Calibri" pitchFamily="34" charset="-122"/>
+                <a:cs typeface="Calibri" pitchFamily="34" charset="-120"/>
+              </a:rPr>
+              <a:t>BENCHMARK</a:t>
+            </a:r>
+            <a:endParaRPr lang="en-US" sz="1200" dirty="0"/>
+          </a:p>
+        </p:txBody>
+      </p:sp>
+      <p:sp>
+        <p:nvSpPr>
+          <p:cNvPr id="15" name="Text 13"/>
+          <p:cNvSpPr/>
+          <p:nvPr/>
+        </p:nvSpPr>
+        <p:spPr>
+          <a:xfrm>
+            <a:off x="3291840" y="3666744"/>
+            <a:ext cx="8046720" cy="548640"/>
+          </a:xfrm>
+          <a:prstGeom prst="rect">
+            <a:avLst/>
+          </a:prstGeom>
+          <a:noFill/>
+          <a:ln/>
+        </p:spPr>
+        <p:txBody>
+          <a:bodyPr wrap="square" lIns="0" tIns="0" rIns="0" bIns="0" rtlCol="0" anchor="ctr"/>
+          <a:lstStyle/>
+          <a:p>
+            <a:pPr indent="0" marL="0">
+              <a:buNone/>
+            </a:pPr>
+            <a:r>
+              <a:rPr lang="en-US" sz="1500" dirty="0">
+                <a:solidFill>
+                  <a:srgbClr val="1F2937"/>
+                </a:solidFill>
+                <a:latin typeface="Calibri" pitchFamily="34" charset="0"/>
+                <a:ea typeface="Calibri" pitchFamily="34" charset="-122"/>
+                <a:cs typeface="Calibri" pitchFamily="34" charset="-120"/>
+              </a:rPr>
+              <a:t>Microsoft AI Agents, From Foundations to Applications</a:t>
+            </a:r>
+            <a:endParaRPr lang="en-US" sz="1500" dirty="0"/>
+          </a:p>
+        </p:txBody>
+      </p:sp>
+      <p:sp>
+        <p:nvSpPr>
+          <p:cNvPr id="16" name="Shape 14"/>
+          <p:cNvSpPr/>
+          <p:nvPr/>
+        </p:nvSpPr>
+        <p:spPr>
+          <a:xfrm>
+            <a:off x="566928" y="4434840"/>
+            <a:ext cx="11064240" cy="1463040"/>
+          </a:xfrm>
+          <a:prstGeom prst="roundRect">
+            <a:avLst>
+              <a:gd name="adj" fmla="val 5625"/>
+            </a:avLst>
+          </a:prstGeom>
+          <a:solidFill>
+            <a:srgbClr val="ECEBFB"/>
+          </a:solidFill>
+          <a:ln w="12700">
+            <a:solidFill>
+              <a:srgbClr val="FFFFFF"/>
+            </a:solidFill>
+            <a:prstDash val="solid"/>
+          </a:ln>
+        </p:spPr>
+      </p:sp>
+      <p:sp>
+        <p:nvSpPr>
+          <p:cNvPr id="17" name="Text 15"/>
+          <p:cNvSpPr/>
+          <p:nvPr/>
+        </p:nvSpPr>
+        <p:spPr>
+          <a:xfrm>
+            <a:off x="841248" y="4617720"/>
+            <a:ext cx="2743200" cy="274320"/>
+          </a:xfrm>
+          <a:prstGeom prst="rect">
+            <a:avLst/>
+          </a:prstGeom>
+          <a:noFill/>
+          <a:ln/>
+        </p:spPr>
+        <p:txBody>
+          <a:bodyPr wrap="square" lIns="0" tIns="0" rIns="0" bIns="0" rtlCol="0" anchor="ctr"/>
+          <a:lstStyle/>
+          <a:p>
+            <a:pPr indent="0" marL="0">
+              <a:buNone/>
+            </a:pPr>
+            <a:r>
+              <a:rPr lang="en-US" sz="1050" b="1" spc="130" kern="0" dirty="0">
+                <a:solidFill>
+                  <a:srgbClr val="3730A3"/>
+                </a:solidFill>
+                <a:latin typeface="Calibri" pitchFamily="34" charset="0"/>
+                <a:ea typeface="Calibri" pitchFamily="34" charset="-122"/>
+                <a:cs typeface="Calibri" pitchFamily="34" charset="-120"/>
+              </a:rPr>
+              <a:t>BOOKS</a:t>
+            </a:r>
+            <a:endParaRPr lang="en-US" sz="1050" dirty="0"/>
+          </a:p>
+        </p:txBody>
+      </p:sp>
+      <p:sp>
+        <p:nvSpPr>
+          <p:cNvPr id="18" name="Text 16"/>
+          <p:cNvSpPr/>
+          <p:nvPr/>
+        </p:nvSpPr>
+        <p:spPr>
+          <a:xfrm>
+            <a:off x="841248" y="4937760"/>
+            <a:ext cx="10515600" cy="868680"/>
           </a:xfrm>
           <a:prstGeom prst="rect">
             <a:avLst/>
@@ -27663,54 +27882,32 @@
           <a:p>
             <a:pPr indent="0" marL="0">
               <a:lnSpc>
-                <a:spcPts val="3200"/>
+                <a:spcPts val="2200"/>
               </a:lnSpc>
               <a:buNone/>
             </a:pPr>
             <a:r>
-              <a:rPr lang="en-US" sz="2100" b="1" dirty="0">
+              <a:rPr lang="en-US" sz="1400" dirty="0">
                 <a:solidFill>
                   <a:srgbClr val="1F2937"/>
                 </a:solidFill>
-                <a:latin typeface="Cambria" pitchFamily="34" charset="0"/>
-                <a:ea typeface="Cambria" pitchFamily="34" charset="-122"/>
-                <a:cs typeface="Cambria" pitchFamily="34" charset="-120"/>
-              </a:rPr>
-              <a:t>"I built a multi agent system. Here is the live link. It is instrumented, so here is a trace of a real request. It runs with least privilege, so here is what it is not allowed to touch. It caught a prompt injection during testing, and here is the fix I wrote for it."</a:t>
-            </a:r>
-            <a:endParaRPr lang="en-US" sz="2100" dirty="0"/>
-          </a:p>
-        </p:txBody>
-      </p:sp>
-      <p:sp>
-        <p:nvSpPr>
-          <p:cNvPr id="6" name="Text 4"/>
-          <p:cNvSpPr/>
-          <p:nvPr/>
-        </p:nvSpPr>
-        <p:spPr>
-          <a:xfrm>
-            <a:off x="566928" y="4846320"/>
-            <a:ext cx="10607040" cy="640080"/>
-          </a:xfrm>
-          <a:prstGeom prst="rect">
-            <a:avLst/>
-          </a:prstGeom>
-          <a:noFill/>
-          <a:ln/>
-        </p:spPr>
-        <p:txBody>
-          <a:bodyPr wrap="square" lIns="0" tIns="0" rIns="0" bIns="0" rtlCol="0" anchor="ctr"/>
-          <a:lstStyle/>
-          <a:p>
-            <a:pPr algn="l" indent="0" marL="0">
+                <a:latin typeface="Calibri" pitchFamily="34" charset="0"/>
+                <a:ea typeface="Calibri" pitchFamily="34" charset="-122"/>
+                <a:cs typeface="Calibri" pitchFamily="34" charset="-120"/>
+              </a:rPr>
+              <a:t>Text: Building Agentic AI Systems, by Anjanava Biswas, Packt.</a:t>
+            </a:r>
+            <a:endParaRPr lang="en-US" sz="1400" dirty="0"/>
+          </a:p>
+          <a:p>
+            <a:pPr indent="0" marL="0">
               <a:lnSpc>
-                <a:spcPts val="2700"/>
+                <a:spcPts val="2200"/>
               </a:lnSpc>
               <a:buNone/>
             </a:pPr>
             <a:r>
-              <a:rPr lang="en-US" sz="1700" dirty="0">
+              <a:rPr lang="en-US" sz="1400" dirty="0">
                 <a:solidFill>
                   <a:srgbClr val="1F2937"/>
                 </a:solidFill>
@@ -27718,9 +27915,9 @@
                 <a:ea typeface="Calibri" pitchFamily="34" charset="-122"/>
                 <a:cs typeface="Calibri" pitchFamily="34" charset="-120"/>
               </a:rPr>
-              <a:t>That sentence is the entire point of the next fifty hours. Everything in the syllabus exists to make it true for you.</a:t>
-            </a:r>
-            <a:endParaRPr lang="en-US" sz="1700" dirty="0"/>
+              <a:t>Reference: Agentic AI Unleashed, by Jayaram Nanduri and Anand Oka, BPB.</a:t>
+            </a:r>
+            <a:endParaRPr lang="en-US" sz="1400" dirty="0"/>
           </a:p>
         </p:txBody>
       </p:sp>
@@ -27735,6 +27932,2019 @@
 <file path=ppt/slides/slide51.xml><?xml version="1.0" encoding="utf-8"?>
 <p:sld xmlns:a="http://schemas.openxmlformats.org/drawingml/2006/main" xmlns:r="http://schemas.openxmlformats.org/officeDocument/2006/relationships" xmlns:p="http://schemas.openxmlformats.org/presentationml/2006/main">
   <p:cSld name="Slide 51">
+    <p:bg>
+      <p:bgPr>
+        <a:solidFill>
+          <a:srgbClr val="FFFFFF"/>
+        </a:solidFill>
+      </p:bgPr>
+    </p:bg>
+    <p:spTree>
+      <p:nvGrpSpPr>
+        <p:cNvPr id="1" name=""/>
+        <p:cNvGrpSpPr/>
+        <p:nvPr/>
+      </p:nvGrpSpPr>
+      <p:grpSpPr>
+        <a:xfrm>
+          <a:off x="0" y="0"/>
+          <a:ext cx="0" cy="0"/>
+          <a:chOff x="0" y="0"/>
+          <a:chExt cx="0" cy="0"/>
+        </a:xfrm>
+      </p:grpSpPr>
+      <p:sp>
+        <p:nvSpPr>
+          <p:cNvPr id="2" name="Text 0"/>
+          <p:cNvSpPr/>
+          <p:nvPr/>
+        </p:nvSpPr>
+        <p:spPr>
+          <a:xfrm>
+            <a:off x="566928" y="384048"/>
+            <a:ext cx="10058400" cy="274320"/>
+          </a:xfrm>
+          <a:prstGeom prst="rect">
+            <a:avLst/>
+          </a:prstGeom>
+          <a:noFill/>
+          <a:ln/>
+        </p:spPr>
+        <p:txBody>
+          <a:bodyPr wrap="square" lIns="0" tIns="0" rIns="0" bIns="0" rtlCol="0" anchor="ctr"/>
+          <a:lstStyle/>
+          <a:p>
+            <a:pPr indent="0" marL="0">
+              <a:buNone/>
+            </a:pPr>
+            <a:r>
+              <a:rPr lang="en-US" sz="1150" b="1" spc="140" kern="0" dirty="0">
+                <a:solidFill>
+                  <a:srgbClr val="0F766E"/>
+                </a:solidFill>
+                <a:latin typeface="Calibri" pitchFamily="34" charset="0"/>
+                <a:ea typeface="Calibri" pitchFamily="34" charset="-122"/>
+                <a:cs typeface="Calibri" pitchFamily="34" charset="-120"/>
+              </a:rPr>
+              <a:t>THE SIX COURSE OUTCOMES</a:t>
+            </a:r>
+            <a:endParaRPr lang="en-US" sz="1150" dirty="0"/>
+          </a:p>
+        </p:txBody>
+      </p:sp>
+      <p:sp>
+        <p:nvSpPr>
+          <p:cNvPr id="3" name="Text 1"/>
+          <p:cNvSpPr/>
+          <p:nvPr/>
+        </p:nvSpPr>
+        <p:spPr>
+          <a:xfrm>
+            <a:off x="566928" y="694944"/>
+            <a:ext cx="11064240" cy="566928"/>
+          </a:xfrm>
+          <a:prstGeom prst="rect">
+            <a:avLst/>
+          </a:prstGeom>
+          <a:noFill/>
+          <a:ln/>
+        </p:spPr>
+        <p:txBody>
+          <a:bodyPr wrap="square" lIns="0" tIns="0" rIns="0" bIns="0" rtlCol="0" anchor="ctr"/>
+          <a:lstStyle/>
+          <a:p>
+            <a:pPr indent="0" marL="0">
+              <a:buNone/>
+            </a:pPr>
+            <a:r>
+              <a:rPr lang="en-US" sz="2700" b="1" dirty="0">
+                <a:solidFill>
+                  <a:srgbClr val="1F2937"/>
+                </a:solidFill>
+                <a:latin typeface="Cambria" pitchFamily="34" charset="0"/>
+                <a:ea typeface="Cambria" pitchFamily="34" charset="-122"/>
+                <a:cs typeface="Cambria" pitchFamily="34" charset="-120"/>
+              </a:rPr>
+              <a:t>What you will be able to do</a:t>
+            </a:r>
+            <a:endParaRPr lang="en-US" sz="2700" dirty="0"/>
+          </a:p>
+        </p:txBody>
+      </p:sp>
+      <p:sp>
+        <p:nvSpPr>
+          <p:cNvPr id="4" name="Text 2"/>
+          <p:cNvSpPr/>
+          <p:nvPr/>
+        </p:nvSpPr>
+        <p:spPr>
+          <a:xfrm>
+            <a:off x="777240" y="1737360"/>
+            <a:ext cx="10332720" cy="3108960"/>
+          </a:xfrm>
+          <a:prstGeom prst="rect">
+            <a:avLst/>
+          </a:prstGeom>
+          <a:noFill/>
+          <a:ln/>
+        </p:spPr>
+        <p:txBody>
+          <a:bodyPr wrap="square" lIns="0" tIns="0" rIns="0" bIns="0" rtlCol="0" anchor="ctr"/>
+          <a:lstStyle/>
+          <a:p>
+            <a:pPr marL="342900" indent="-342900">
+              <a:lnSpc>
+                <a:spcPts val="2300"/>
+              </a:lnSpc>
+              <a:spcAft>
+                <a:spcPts val="1100"/>
+              </a:spcAft>
+              <a:buSzPct val="100000"/>
+              <a:buChar char="●"/>
+            </a:pPr>
+            <a:r>
+              <a:rPr lang="en-US" sz="1550" dirty="0">
+                <a:solidFill>
+                  <a:srgbClr val="1F2937"/>
+                </a:solidFill>
+                <a:latin typeface="Calibri" pitchFamily="34" charset="0"/>
+                <a:ea typeface="Calibri" pitchFamily="34" charset="-122"/>
+                <a:cs typeface="Calibri" pitchFamily="34" charset="-120"/>
+              </a:rPr>
+              <a:t>CO1  Build intelligent AI agents using Microsoft Foundry and modern orchestration frameworks.</a:t>
+            </a:r>
+            <a:endParaRPr lang="en-US" sz="1550" dirty="0"/>
+          </a:p>
+          <a:p>
+            <a:pPr marL="342900" indent="-342900">
+              <a:lnSpc>
+                <a:spcPts val="2300"/>
+              </a:lnSpc>
+              <a:spcAft>
+                <a:spcPts val="1100"/>
+              </a:spcAft>
+              <a:buSzPct val="100000"/>
+              <a:buChar char="●"/>
+            </a:pPr>
+            <a:r>
+              <a:rPr lang="en-US" sz="1550" dirty="0">
+                <a:solidFill>
+                  <a:srgbClr val="1F2937"/>
+                </a:solidFill>
+                <a:latin typeface="Calibri" pitchFamily="34" charset="0"/>
+                <a:ea typeface="Calibri" pitchFamily="34" charset="-122"/>
+                <a:cs typeface="Calibri" pitchFamily="34" charset="-120"/>
+              </a:rPr>
+              <a:t>CO2  Build autonomous and conversational agents that reason, remember, plan, and use tools.</a:t>
+            </a:r>
+            <a:endParaRPr lang="en-US" sz="1550" dirty="0"/>
+          </a:p>
+          <a:p>
+            <a:pPr marL="342900" indent="-342900">
+              <a:lnSpc>
+                <a:spcPts val="2300"/>
+              </a:lnSpc>
+              <a:spcAft>
+                <a:spcPts val="1100"/>
+              </a:spcAft>
+              <a:buSzPct val="100000"/>
+              <a:buChar char="●"/>
+            </a:pPr>
+            <a:r>
+              <a:rPr lang="en-US" sz="1550" dirty="0">
+                <a:solidFill>
+                  <a:srgbClr val="1F2937"/>
+                </a:solidFill>
+                <a:latin typeface="Calibri" pitchFamily="34" charset="0"/>
+                <a:ea typeface="Calibri" pitchFamily="34" charset="-122"/>
+                <a:cs typeface="Calibri" pitchFamily="34" charset="-120"/>
+              </a:rPr>
+              <a:t>CO3  Build production ready agents with Python, Semantic Kernel, AutoGen, and Azure services.</a:t>
+            </a:r>
+            <a:endParaRPr lang="en-US" sz="1550" dirty="0"/>
+          </a:p>
+          <a:p>
+            <a:pPr marL="342900" indent="-342900">
+              <a:lnSpc>
+                <a:spcPts val="2300"/>
+              </a:lnSpc>
+              <a:spcAft>
+                <a:spcPts val="1100"/>
+              </a:spcAft>
+              <a:buSzPct val="100000"/>
+              <a:buChar char="●"/>
+            </a:pPr>
+            <a:r>
+              <a:rPr lang="en-US" sz="1550" dirty="0">
+                <a:solidFill>
+                  <a:srgbClr val="1F2937"/>
+                </a:solidFill>
+                <a:latin typeface="Calibri" pitchFamily="34" charset="0"/>
+                <a:ea typeface="Calibri" pitchFamily="34" charset="-122"/>
+                <a:cs typeface="Calibri" pitchFamily="34" charset="-120"/>
+              </a:rPr>
+              <a:t>CO4  Run multi agent systems for enterprise workflow automation and task execution.</a:t>
+            </a:r>
+            <a:endParaRPr lang="en-US" sz="1550" dirty="0"/>
+          </a:p>
+          <a:p>
+            <a:pPr marL="342900" indent="-342900">
+              <a:lnSpc>
+                <a:spcPts val="2300"/>
+              </a:lnSpc>
+              <a:spcAft>
+                <a:spcPts val="1100"/>
+              </a:spcAft>
+              <a:buSzPct val="100000"/>
+              <a:buChar char="●"/>
+            </a:pPr>
+            <a:r>
+              <a:rPr lang="en-US" sz="1550" dirty="0">
+                <a:solidFill>
+                  <a:srgbClr val="1F2937"/>
+                </a:solidFill>
+                <a:latin typeface="Calibri" pitchFamily="34" charset="0"/>
+                <a:ea typeface="Calibri" pitchFamily="34" charset="-122"/>
+                <a:cs typeface="Calibri" pitchFamily="34" charset="-120"/>
+              </a:rPr>
+              <a:t>CO5  Apply prompt engineering, testing, observability, and deployment for reliable operation.</a:t>
+            </a:r>
+            <a:endParaRPr lang="en-US" sz="1550" dirty="0"/>
+          </a:p>
+          <a:p>
+            <a:pPr marL="342900" indent="-342900">
+              <a:lnSpc>
+                <a:spcPts val="2300"/>
+              </a:lnSpc>
+              <a:spcAft>
+                <a:spcPts val="1100"/>
+              </a:spcAft>
+              <a:buSzPct val="100000"/>
+              <a:buChar char="●"/>
+            </a:pPr>
+            <a:r>
+              <a:rPr lang="en-US" sz="1550" dirty="0">
+                <a:solidFill>
+                  <a:srgbClr val="1F2937"/>
+                </a:solidFill>
+                <a:latin typeface="Calibri" pitchFamily="34" charset="0"/>
+                <a:ea typeface="Calibri" pitchFamily="34" charset="-122"/>
+                <a:cs typeface="Calibri" pitchFamily="34" charset="-120"/>
+              </a:rPr>
+              <a:t>CO6  Practice responsible AI, security, governance, and scalable deployment.</a:t>
+            </a:r>
+            <a:endParaRPr lang="en-US" sz="1550" dirty="0"/>
+          </a:p>
+        </p:txBody>
+      </p:sp>
+      <p:sp>
+        <p:nvSpPr>
+          <p:cNvPr id="5" name="Shape 3"/>
+          <p:cNvSpPr/>
+          <p:nvPr/>
+        </p:nvSpPr>
+        <p:spPr>
+          <a:xfrm>
+            <a:off x="566928" y="5029200"/>
+            <a:ext cx="11064240" cy="914400"/>
+          </a:xfrm>
+          <a:prstGeom prst="roundRect">
+            <a:avLst>
+              <a:gd name="adj" fmla="val 9000"/>
+            </a:avLst>
+          </a:prstGeom>
+          <a:solidFill>
+            <a:srgbClr val="F7F9FB"/>
+          </a:solidFill>
+          <a:ln w="12700">
+            <a:solidFill>
+              <a:srgbClr val="E3E8EE"/>
+            </a:solidFill>
+            <a:prstDash val="solid"/>
+          </a:ln>
+        </p:spPr>
+      </p:sp>
+      <p:sp>
+        <p:nvSpPr>
+          <p:cNvPr id="6" name="Text 4"/>
+          <p:cNvSpPr/>
+          <p:nvPr/>
+        </p:nvSpPr>
+        <p:spPr>
+          <a:xfrm>
+            <a:off x="841248" y="5175504"/>
+            <a:ext cx="2743200" cy="237744"/>
+          </a:xfrm>
+          <a:prstGeom prst="rect">
+            <a:avLst/>
+          </a:prstGeom>
+          <a:noFill/>
+          <a:ln/>
+        </p:spPr>
+        <p:txBody>
+          <a:bodyPr wrap="square" lIns="0" tIns="0" rIns="0" bIns="0" rtlCol="0" anchor="ctr"/>
+          <a:lstStyle/>
+          <a:p>
+            <a:pPr indent="0" marL="0">
+              <a:buNone/>
+            </a:pPr>
+            <a:r>
+              <a:rPr lang="en-US" sz="1050" b="1" spc="130" kern="0" dirty="0">
+                <a:solidFill>
+                  <a:srgbClr val="0F766E"/>
+                </a:solidFill>
+                <a:latin typeface="Calibri" pitchFamily="34" charset="0"/>
+                <a:ea typeface="Calibri" pitchFamily="34" charset="-122"/>
+                <a:cs typeface="Calibri" pitchFamily="34" charset="-120"/>
+              </a:rPr>
+              <a:t>HOLD ON TO THIS</a:t>
+            </a:r>
+            <a:endParaRPr lang="en-US" sz="1050" dirty="0"/>
+          </a:p>
+        </p:txBody>
+      </p:sp>
+      <p:sp>
+        <p:nvSpPr>
+          <p:cNvPr id="7" name="Text 5"/>
+          <p:cNvSpPr/>
+          <p:nvPr/>
+        </p:nvSpPr>
+        <p:spPr>
+          <a:xfrm>
+            <a:off x="841248" y="5431536"/>
+            <a:ext cx="10515600" cy="384048"/>
+          </a:xfrm>
+          <a:prstGeom prst="rect">
+            <a:avLst/>
+          </a:prstGeom>
+          <a:noFill/>
+          <a:ln/>
+        </p:spPr>
+        <p:txBody>
+          <a:bodyPr wrap="square" lIns="0" tIns="0" rIns="0" bIns="0" rtlCol="0" anchor="ctr"/>
+          <a:lstStyle/>
+          <a:p>
+            <a:pPr indent="0" marL="0">
+              <a:lnSpc>
+                <a:spcPts val="2000"/>
+              </a:lnSpc>
+              <a:buNone/>
+            </a:pPr>
+            <a:r>
+              <a:rPr lang="en-US" sz="1450" dirty="0">
+                <a:solidFill>
+                  <a:srgbClr val="1F2937"/>
+                </a:solidFill>
+                <a:latin typeface="Calibri" pitchFamily="34" charset="0"/>
+                <a:ea typeface="Calibri" pitchFamily="34" charset="-122"/>
+                <a:cs typeface="Calibri" pitchFamily="34" charset="-120"/>
+              </a:rPr>
+              <a:t>These are the promises the university holds me to. Notice every one of them starts with the word build. That is not an accident, and it is why nearly all your marks come from things you make rather than things you memorise.</a:t>
+            </a:r>
+            <a:endParaRPr lang="en-US" sz="1450" dirty="0"/>
+          </a:p>
+        </p:txBody>
+      </p:sp>
+    </p:spTree>
+  </p:cSld>
+  <p:clrMapOvr>
+    <a:masterClrMapping/>
+  </p:clrMapOvr>
+</p:sld>
+</file>
+
+<file path=ppt/slides/slide52.xml><?xml version="1.0" encoding="utf-8"?>
+<p:sld xmlns:a="http://schemas.openxmlformats.org/drawingml/2006/main" xmlns:r="http://schemas.openxmlformats.org/officeDocument/2006/relationships" xmlns:p="http://schemas.openxmlformats.org/presentationml/2006/main">
+  <p:cSld name="Slide 52">
+    <p:bg>
+      <p:bgPr>
+        <a:solidFill>
+          <a:srgbClr val="FFFFFF"/>
+        </a:solidFill>
+      </p:bgPr>
+    </p:bg>
+    <p:spTree>
+      <p:nvGrpSpPr>
+        <p:cNvPr id="1" name=""/>
+        <p:cNvGrpSpPr/>
+        <p:nvPr/>
+      </p:nvGrpSpPr>
+      <p:grpSpPr>
+        <a:xfrm>
+          <a:off x="0" y="0"/>
+          <a:ext cx="0" cy="0"/>
+          <a:chOff x="0" y="0"/>
+          <a:chExt cx="0" cy="0"/>
+        </a:xfrm>
+      </p:grpSpPr>
+      <p:sp>
+        <p:nvSpPr>
+          <p:cNvPr id="2" name="Text 0"/>
+          <p:cNvSpPr/>
+          <p:nvPr/>
+        </p:nvSpPr>
+        <p:spPr>
+          <a:xfrm>
+            <a:off x="566928" y="384048"/>
+            <a:ext cx="10058400" cy="274320"/>
+          </a:xfrm>
+          <a:prstGeom prst="rect">
+            <a:avLst/>
+          </a:prstGeom>
+          <a:noFill/>
+          <a:ln/>
+        </p:spPr>
+        <p:txBody>
+          <a:bodyPr wrap="square" lIns="0" tIns="0" rIns="0" bIns="0" rtlCol="0" anchor="ctr"/>
+          <a:lstStyle/>
+          <a:p>
+            <a:pPr indent="0" marL="0">
+              <a:buNone/>
+            </a:pPr>
+            <a:r>
+              <a:rPr lang="en-US" sz="1150" b="1" spc="140" kern="0" dirty="0">
+                <a:solidFill>
+                  <a:srgbClr val="0F766E"/>
+                </a:solidFill>
+                <a:latin typeface="Calibri" pitchFamily="34" charset="0"/>
+                <a:ea typeface="Calibri" pitchFamily="34" charset="-122"/>
+                <a:cs typeface="Calibri" pitchFamily="34" charset="-120"/>
+              </a:rPr>
+              <a:t>ACADEMIC TASK SCHEDULE</a:t>
+            </a:r>
+            <a:endParaRPr lang="en-US" sz="1150" dirty="0"/>
+          </a:p>
+        </p:txBody>
+      </p:sp>
+      <p:sp>
+        <p:nvSpPr>
+          <p:cNvPr id="3" name="Text 1"/>
+          <p:cNvSpPr/>
+          <p:nvPr/>
+        </p:nvSpPr>
+        <p:spPr>
+          <a:xfrm>
+            <a:off x="566928" y="694944"/>
+            <a:ext cx="11064240" cy="566928"/>
+          </a:xfrm>
+          <a:prstGeom prst="rect">
+            <a:avLst/>
+          </a:prstGeom>
+          <a:noFill/>
+          <a:ln/>
+        </p:spPr>
+        <p:txBody>
+          <a:bodyPr wrap="square" lIns="0" tIns="0" rIns="0" bIns="0" rtlCol="0" anchor="ctr"/>
+          <a:lstStyle/>
+          <a:p>
+            <a:pPr indent="0" marL="0">
+              <a:buNone/>
+            </a:pPr>
+            <a:r>
+              <a:rPr lang="en-US" sz="2700" b="1" dirty="0">
+                <a:solidFill>
+                  <a:srgbClr val="1F2937"/>
+                </a:solidFill>
+                <a:latin typeface="Cambria" pitchFamily="34" charset="0"/>
+                <a:ea typeface="Cambria" pitchFamily="34" charset="-122"/>
+                <a:cs typeface="Cambria" pitchFamily="34" charset="-120"/>
+              </a:rPr>
+              <a:t>The three graded checkpoints</a:t>
+            </a:r>
+            <a:endParaRPr lang="en-US" sz="2700" dirty="0"/>
+          </a:p>
+        </p:txBody>
+      </p:sp>
+      <p:sp>
+        <p:nvSpPr>
+          <p:cNvPr id="4" name="Shape 2"/>
+          <p:cNvSpPr/>
+          <p:nvPr/>
+        </p:nvSpPr>
+        <p:spPr>
+          <a:xfrm>
+            <a:off x="566928" y="1874520"/>
+            <a:ext cx="11064240" cy="932688"/>
+          </a:xfrm>
+          <a:prstGeom prst="roundRect">
+            <a:avLst>
+              <a:gd name="adj" fmla="val 8824"/>
+            </a:avLst>
+          </a:prstGeom>
+          <a:solidFill>
+            <a:srgbClr val="000000"/>
+          </a:solidFill>
+          <a:ln w="12700">
+            <a:solidFill>
+              <a:srgbClr val="FFFFFF"/>
+            </a:solidFill>
+            <a:prstDash val="solid"/>
+          </a:ln>
+        </p:spPr>
+      </p:sp>
+      <p:sp>
+        <p:nvSpPr>
+          <p:cNvPr id="5" name="Text 3"/>
+          <p:cNvSpPr/>
+          <p:nvPr/>
+        </p:nvSpPr>
+        <p:spPr>
+          <a:xfrm>
+            <a:off x="822960" y="1874520"/>
+            <a:ext cx="2011680" cy="932688"/>
+          </a:xfrm>
+          <a:prstGeom prst="rect">
+            <a:avLst/>
+          </a:prstGeom>
+          <a:noFill/>
+          <a:ln/>
+        </p:spPr>
+        <p:txBody>
+          <a:bodyPr wrap="square" lIns="0" tIns="0" rIns="0" bIns="0" rtlCol="0" anchor="ctr"/>
+          <a:lstStyle/>
+          <a:p>
+            <a:pPr indent="0" marL="0">
+              <a:buNone/>
+            </a:pPr>
+            <a:r>
+              <a:rPr lang="en-US" sz="1250" b="1" spc="110" kern="0" dirty="0">
+                <a:solidFill>
+                  <a:srgbClr val="E6FBF7"/>
+                </a:solidFill>
+                <a:latin typeface="Calibri" pitchFamily="34" charset="0"/>
+                <a:ea typeface="Calibri" pitchFamily="34" charset="-122"/>
+                <a:cs typeface="Calibri" pitchFamily="34" charset="-120"/>
+              </a:rPr>
+              <a:t>PRACTICAL 1</a:t>
+            </a:r>
+            <a:endParaRPr lang="en-US" sz="1250" dirty="0"/>
+          </a:p>
+        </p:txBody>
+      </p:sp>
+      <p:sp>
+        <p:nvSpPr>
+          <p:cNvPr id="6" name="Text 4"/>
+          <p:cNvSpPr/>
+          <p:nvPr/>
+        </p:nvSpPr>
+        <p:spPr>
+          <a:xfrm>
+            <a:off x="2880360" y="1874520"/>
+            <a:ext cx="1828800" cy="932688"/>
+          </a:xfrm>
+          <a:prstGeom prst="rect">
+            <a:avLst/>
+          </a:prstGeom>
+          <a:noFill/>
+          <a:ln/>
+        </p:spPr>
+        <p:txBody>
+          <a:bodyPr wrap="square" lIns="0" tIns="0" rIns="0" bIns="0" rtlCol="0" anchor="ctr"/>
+          <a:lstStyle/>
+          <a:p>
+            <a:pPr indent="0" marL="0">
+              <a:buNone/>
+            </a:pPr>
+            <a:r>
+              <a:rPr lang="en-US" sz="1500" b="1" dirty="0">
+                <a:solidFill>
+                  <a:srgbClr val="1F2937"/>
+                </a:solidFill>
+                <a:latin typeface="Cambria" pitchFamily="34" charset="0"/>
+                <a:ea typeface="Cambria" pitchFamily="34" charset="-122"/>
+                <a:cs typeface="Cambria" pitchFamily="34" charset="-120"/>
+              </a:rPr>
+              <a:t>Weeks 5 to 6</a:t>
+            </a:r>
+            <a:endParaRPr lang="en-US" sz="1500" dirty="0"/>
+          </a:p>
+        </p:txBody>
+      </p:sp>
+      <p:sp>
+        <p:nvSpPr>
+          <p:cNvPr id="7" name="Text 5"/>
+          <p:cNvSpPr/>
+          <p:nvPr/>
+        </p:nvSpPr>
+        <p:spPr>
+          <a:xfrm>
+            <a:off x="4846320" y="1874520"/>
+            <a:ext cx="5486400" cy="932688"/>
+          </a:xfrm>
+          <a:prstGeom prst="rect">
+            <a:avLst/>
+          </a:prstGeom>
+          <a:noFill/>
+          <a:ln/>
+        </p:spPr>
+        <p:txBody>
+          <a:bodyPr wrap="square" lIns="0" tIns="0" rIns="0" bIns="0" rtlCol="0" anchor="ctr"/>
+          <a:lstStyle/>
+          <a:p>
+            <a:pPr indent="0" marL="0">
+              <a:lnSpc>
+                <a:spcPts val="1800"/>
+              </a:lnSpc>
+              <a:buNone/>
+            </a:pPr>
+            <a:r>
+              <a:rPr lang="en-US" sz="1350" dirty="0">
+                <a:solidFill>
+                  <a:srgbClr val="6B7280"/>
+                </a:solidFill>
+                <a:latin typeface="Calibri" pitchFamily="34" charset="0"/>
+                <a:ea typeface="Calibri" pitchFamily="34" charset="-122"/>
+                <a:cs typeface="Calibri" pitchFamily="34" charset="-120"/>
+              </a:rPr>
+              <a:t>Units 1 and 2. Agents and Foundry, and building intelligent workflows.</a:t>
+            </a:r>
+            <a:endParaRPr lang="en-US" sz="1350" dirty="0"/>
+          </a:p>
+        </p:txBody>
+      </p:sp>
+      <p:sp>
+        <p:nvSpPr>
+          <p:cNvPr id="8" name="Text 6"/>
+          <p:cNvSpPr/>
+          <p:nvPr/>
+        </p:nvSpPr>
+        <p:spPr>
+          <a:xfrm>
+            <a:off x="10424160" y="1874520"/>
+            <a:ext cx="914400" cy="932688"/>
+          </a:xfrm>
+          <a:prstGeom prst="rect">
+            <a:avLst/>
+          </a:prstGeom>
+          <a:noFill/>
+          <a:ln/>
+        </p:spPr>
+        <p:txBody>
+          <a:bodyPr wrap="square" lIns="0" tIns="0" rIns="0" bIns="0" rtlCol="0" anchor="ctr"/>
+          <a:lstStyle/>
+          <a:p>
+            <a:pPr algn="r" indent="0" marL="0">
+              <a:buNone/>
+            </a:pPr>
+            <a:r>
+              <a:rPr lang="en-US" sz="2200" b="1" dirty="0">
+                <a:solidFill>
+                  <a:srgbClr val="E6FBF7"/>
+                </a:solidFill>
+                <a:latin typeface="Cambria" pitchFamily="34" charset="0"/>
+                <a:ea typeface="Cambria" pitchFamily="34" charset="-122"/>
+                <a:cs typeface="Cambria" pitchFamily="34" charset="-120"/>
+              </a:rPr>
+              <a:t>30</a:t>
+            </a:r>
+            <a:endParaRPr lang="en-US" sz="2200" dirty="0"/>
+          </a:p>
+        </p:txBody>
+      </p:sp>
+      <p:sp>
+        <p:nvSpPr>
+          <p:cNvPr id="9" name="Shape 7"/>
+          <p:cNvSpPr/>
+          <p:nvPr/>
+        </p:nvSpPr>
+        <p:spPr>
+          <a:xfrm>
+            <a:off x="566928" y="2971800"/>
+            <a:ext cx="11064240" cy="932688"/>
+          </a:xfrm>
+          <a:prstGeom prst="roundRect">
+            <a:avLst>
+              <a:gd name="adj" fmla="val 8824"/>
+            </a:avLst>
+          </a:prstGeom>
+          <a:solidFill>
+            <a:srgbClr val="000000"/>
+          </a:solidFill>
+          <a:ln w="12700">
+            <a:solidFill>
+              <a:srgbClr val="FFFFFF"/>
+            </a:solidFill>
+            <a:prstDash val="solid"/>
+          </a:ln>
+        </p:spPr>
+      </p:sp>
+      <p:sp>
+        <p:nvSpPr>
+          <p:cNvPr id="10" name="Text 8"/>
+          <p:cNvSpPr/>
+          <p:nvPr/>
+        </p:nvSpPr>
+        <p:spPr>
+          <a:xfrm>
+            <a:off x="822960" y="2971800"/>
+            <a:ext cx="2011680" cy="932688"/>
+          </a:xfrm>
+          <a:prstGeom prst="rect">
+            <a:avLst/>
+          </a:prstGeom>
+          <a:noFill/>
+          <a:ln/>
+        </p:spPr>
+        <p:txBody>
+          <a:bodyPr wrap="square" lIns="0" tIns="0" rIns="0" bIns="0" rtlCol="0" anchor="ctr"/>
+          <a:lstStyle/>
+          <a:p>
+            <a:pPr indent="0" marL="0">
+              <a:buNone/>
+            </a:pPr>
+            <a:r>
+              <a:rPr lang="en-US" sz="1250" b="1" spc="110" kern="0" dirty="0">
+                <a:solidFill>
+                  <a:srgbClr val="ECEBFB"/>
+                </a:solidFill>
+                <a:latin typeface="Calibri" pitchFamily="34" charset="0"/>
+                <a:ea typeface="Calibri" pitchFamily="34" charset="-122"/>
+                <a:cs typeface="Calibri" pitchFamily="34" charset="-120"/>
+              </a:rPr>
+              <a:t>PRACTICAL 2</a:t>
+            </a:r>
+            <a:endParaRPr lang="en-US" sz="1250" dirty="0"/>
+          </a:p>
+        </p:txBody>
+      </p:sp>
+      <p:sp>
+        <p:nvSpPr>
+          <p:cNvPr id="11" name="Text 9"/>
+          <p:cNvSpPr/>
+          <p:nvPr/>
+        </p:nvSpPr>
+        <p:spPr>
+          <a:xfrm>
+            <a:off x="2880360" y="2971800"/>
+            <a:ext cx="1828800" cy="932688"/>
+          </a:xfrm>
+          <a:prstGeom prst="rect">
+            <a:avLst/>
+          </a:prstGeom>
+          <a:noFill/>
+          <a:ln/>
+        </p:spPr>
+        <p:txBody>
+          <a:bodyPr wrap="square" lIns="0" tIns="0" rIns="0" bIns="0" rtlCol="0" anchor="ctr"/>
+          <a:lstStyle/>
+          <a:p>
+            <a:pPr indent="0" marL="0">
+              <a:buNone/>
+            </a:pPr>
+            <a:r>
+              <a:rPr lang="en-US" sz="1500" b="1" dirty="0">
+                <a:solidFill>
+                  <a:srgbClr val="1F2937"/>
+                </a:solidFill>
+                <a:latin typeface="Cambria" pitchFamily="34" charset="0"/>
+                <a:ea typeface="Cambria" pitchFamily="34" charset="-122"/>
+                <a:cs typeface="Cambria" pitchFamily="34" charset="-120"/>
+              </a:rPr>
+              <a:t>Weeks 10 to 11</a:t>
+            </a:r>
+            <a:endParaRPr lang="en-US" sz="1500" dirty="0"/>
+          </a:p>
+        </p:txBody>
+      </p:sp>
+      <p:sp>
+        <p:nvSpPr>
+          <p:cNvPr id="12" name="Text 10"/>
+          <p:cNvSpPr/>
+          <p:nvPr/>
+        </p:nvSpPr>
+        <p:spPr>
+          <a:xfrm>
+            <a:off x="4846320" y="2971800"/>
+            <a:ext cx="5486400" cy="932688"/>
+          </a:xfrm>
+          <a:prstGeom prst="rect">
+            <a:avLst/>
+          </a:prstGeom>
+          <a:noFill/>
+          <a:ln/>
+        </p:spPr>
+        <p:txBody>
+          <a:bodyPr wrap="square" lIns="0" tIns="0" rIns="0" bIns="0" rtlCol="0" anchor="ctr"/>
+          <a:lstStyle/>
+          <a:p>
+            <a:pPr indent="0" marL="0">
+              <a:lnSpc>
+                <a:spcPts val="1800"/>
+              </a:lnSpc>
+              <a:buNone/>
+            </a:pPr>
+            <a:r>
+              <a:rPr lang="en-US" sz="1350" dirty="0">
+                <a:solidFill>
+                  <a:srgbClr val="6B7280"/>
+                </a:solidFill>
+                <a:latin typeface="Calibri" pitchFamily="34" charset="0"/>
+                <a:ea typeface="Calibri" pitchFamily="34" charset="-122"/>
+                <a:cs typeface="Calibri" pitchFamily="34" charset="-120"/>
+              </a:rPr>
+              <a:t>Units 3 and 4. Development with Python and frameworks, and multi agent systems.</a:t>
+            </a:r>
+            <a:endParaRPr lang="en-US" sz="1350" dirty="0"/>
+          </a:p>
+        </p:txBody>
+      </p:sp>
+      <p:sp>
+        <p:nvSpPr>
+          <p:cNvPr id="13" name="Text 11"/>
+          <p:cNvSpPr/>
+          <p:nvPr/>
+        </p:nvSpPr>
+        <p:spPr>
+          <a:xfrm>
+            <a:off x="10424160" y="2971800"/>
+            <a:ext cx="914400" cy="932688"/>
+          </a:xfrm>
+          <a:prstGeom prst="rect">
+            <a:avLst/>
+          </a:prstGeom>
+          <a:noFill/>
+          <a:ln/>
+        </p:spPr>
+        <p:txBody>
+          <a:bodyPr wrap="square" lIns="0" tIns="0" rIns="0" bIns="0" rtlCol="0" anchor="ctr"/>
+          <a:lstStyle/>
+          <a:p>
+            <a:pPr algn="r" indent="0" marL="0">
+              <a:buNone/>
+            </a:pPr>
+            <a:r>
+              <a:rPr lang="en-US" sz="2200" b="1" dirty="0">
+                <a:solidFill>
+                  <a:srgbClr val="ECEBFB"/>
+                </a:solidFill>
+                <a:latin typeface="Cambria" pitchFamily="34" charset="0"/>
+                <a:ea typeface="Cambria" pitchFamily="34" charset="-122"/>
+                <a:cs typeface="Cambria" pitchFamily="34" charset="-120"/>
+              </a:rPr>
+              <a:t>30</a:t>
+            </a:r>
+            <a:endParaRPr lang="en-US" sz="2200" dirty="0"/>
+          </a:p>
+        </p:txBody>
+      </p:sp>
+      <p:sp>
+        <p:nvSpPr>
+          <p:cNvPr id="14" name="Shape 12"/>
+          <p:cNvSpPr/>
+          <p:nvPr/>
+        </p:nvSpPr>
+        <p:spPr>
+          <a:xfrm>
+            <a:off x="566928" y="4069080"/>
+            <a:ext cx="11064240" cy="932688"/>
+          </a:xfrm>
+          <a:prstGeom prst="roundRect">
+            <a:avLst>
+              <a:gd name="adj" fmla="val 8824"/>
+            </a:avLst>
+          </a:prstGeom>
+          <a:solidFill>
+            <a:srgbClr val="000000"/>
+          </a:solidFill>
+          <a:ln w="12700">
+            <a:solidFill>
+              <a:srgbClr val="FFFFFF"/>
+            </a:solidFill>
+            <a:prstDash val="solid"/>
+          </a:ln>
+        </p:spPr>
+      </p:sp>
+      <p:sp>
+        <p:nvSpPr>
+          <p:cNvPr id="15" name="Text 13"/>
+          <p:cNvSpPr/>
+          <p:nvPr/>
+        </p:nvSpPr>
+        <p:spPr>
+          <a:xfrm>
+            <a:off x="822960" y="4069080"/>
+            <a:ext cx="2011680" cy="932688"/>
+          </a:xfrm>
+          <a:prstGeom prst="rect">
+            <a:avLst/>
+          </a:prstGeom>
+          <a:noFill/>
+          <a:ln/>
+        </p:spPr>
+        <p:txBody>
+          <a:bodyPr wrap="square" lIns="0" tIns="0" rIns="0" bIns="0" rtlCol="0" anchor="ctr"/>
+          <a:lstStyle/>
+          <a:p>
+            <a:pPr indent="0" marL="0">
+              <a:buNone/>
+            </a:pPr>
+            <a:r>
+              <a:rPr lang="en-US" sz="1250" b="1" spc="110" kern="0" dirty="0">
+                <a:solidFill>
+                  <a:srgbClr val="FEF6E0"/>
+                </a:solidFill>
+                <a:latin typeface="Calibri" pitchFamily="34" charset="0"/>
+                <a:ea typeface="Calibri" pitchFamily="34" charset="-122"/>
+                <a:cs typeface="Calibri" pitchFamily="34" charset="-120"/>
+              </a:rPr>
+              <a:t>PRACTICAL 3</a:t>
+            </a:r>
+            <a:endParaRPr lang="en-US" sz="1250" dirty="0"/>
+          </a:p>
+        </p:txBody>
+      </p:sp>
+      <p:sp>
+        <p:nvSpPr>
+          <p:cNvPr id="16" name="Text 14"/>
+          <p:cNvSpPr/>
+          <p:nvPr/>
+        </p:nvSpPr>
+        <p:spPr>
+          <a:xfrm>
+            <a:off x="2880360" y="4069080"/>
+            <a:ext cx="1828800" cy="932688"/>
+          </a:xfrm>
+          <a:prstGeom prst="rect">
+            <a:avLst/>
+          </a:prstGeom>
+          <a:noFill/>
+          <a:ln/>
+        </p:spPr>
+        <p:txBody>
+          <a:bodyPr wrap="square" lIns="0" tIns="0" rIns="0" bIns="0" rtlCol="0" anchor="ctr"/>
+          <a:lstStyle/>
+          <a:p>
+            <a:pPr indent="0" marL="0">
+              <a:buNone/>
+            </a:pPr>
+            <a:r>
+              <a:rPr lang="en-US" sz="1500" b="1" dirty="0">
+                <a:solidFill>
+                  <a:srgbClr val="1F2937"/>
+                </a:solidFill>
+                <a:latin typeface="Cambria" pitchFamily="34" charset="0"/>
+                <a:ea typeface="Cambria" pitchFamily="34" charset="-122"/>
+                <a:cs typeface="Cambria" pitchFamily="34" charset="-120"/>
+              </a:rPr>
+              <a:t>Weeks 11 to 12</a:t>
+            </a:r>
+            <a:endParaRPr lang="en-US" sz="1500" dirty="0"/>
+          </a:p>
+        </p:txBody>
+      </p:sp>
+      <p:sp>
+        <p:nvSpPr>
+          <p:cNvPr id="17" name="Text 15"/>
+          <p:cNvSpPr/>
+          <p:nvPr/>
+        </p:nvSpPr>
+        <p:spPr>
+          <a:xfrm>
+            <a:off x="4846320" y="4069080"/>
+            <a:ext cx="5486400" cy="932688"/>
+          </a:xfrm>
+          <a:prstGeom prst="rect">
+            <a:avLst/>
+          </a:prstGeom>
+          <a:noFill/>
+          <a:ln/>
+        </p:spPr>
+        <p:txBody>
+          <a:bodyPr wrap="square" lIns="0" tIns="0" rIns="0" bIns="0" rtlCol="0" anchor="ctr"/>
+          <a:lstStyle/>
+          <a:p>
+            <a:pPr indent="0" marL="0">
+              <a:lnSpc>
+                <a:spcPts val="1800"/>
+              </a:lnSpc>
+              <a:buNone/>
+            </a:pPr>
+            <a:r>
+              <a:rPr lang="en-US" sz="1350" dirty="0">
+                <a:solidFill>
+                  <a:srgbClr val="6B7280"/>
+                </a:solidFill>
+                <a:latin typeface="Calibri" pitchFamily="34" charset="0"/>
+                <a:ea typeface="Calibri" pitchFamily="34" charset="-122"/>
+                <a:cs typeface="Calibri" pitchFamily="34" charset="-120"/>
+              </a:rPr>
+              <a:t>A test across Units 1 to 4. Also your chance to lift a weak earlier score.</a:t>
+            </a:r>
+            <a:endParaRPr lang="en-US" sz="1350" dirty="0"/>
+          </a:p>
+        </p:txBody>
+      </p:sp>
+      <p:sp>
+        <p:nvSpPr>
+          <p:cNvPr id="18" name="Text 16"/>
+          <p:cNvSpPr/>
+          <p:nvPr/>
+        </p:nvSpPr>
+        <p:spPr>
+          <a:xfrm>
+            <a:off x="10424160" y="4069080"/>
+            <a:ext cx="914400" cy="932688"/>
+          </a:xfrm>
+          <a:prstGeom prst="rect">
+            <a:avLst/>
+          </a:prstGeom>
+          <a:noFill/>
+          <a:ln/>
+        </p:spPr>
+        <p:txBody>
+          <a:bodyPr wrap="square" lIns="0" tIns="0" rIns="0" bIns="0" rtlCol="0" anchor="ctr"/>
+          <a:lstStyle/>
+          <a:p>
+            <a:pPr algn="r" indent="0" marL="0">
+              <a:buNone/>
+            </a:pPr>
+            <a:r>
+              <a:rPr lang="en-US" sz="2200" b="1" dirty="0">
+                <a:solidFill>
+                  <a:srgbClr val="FEF6E0"/>
+                </a:solidFill>
+                <a:latin typeface="Cambria" pitchFamily="34" charset="0"/>
+                <a:ea typeface="Cambria" pitchFamily="34" charset="-122"/>
+                <a:cs typeface="Cambria" pitchFamily="34" charset="-120"/>
+              </a:rPr>
+              <a:t>30</a:t>
+            </a:r>
+            <a:endParaRPr lang="en-US" sz="2200" dirty="0"/>
+          </a:p>
+        </p:txBody>
+      </p:sp>
+      <p:sp>
+        <p:nvSpPr>
+          <p:cNvPr id="19" name="Shape 17"/>
+          <p:cNvSpPr/>
+          <p:nvPr/>
+        </p:nvSpPr>
+        <p:spPr>
+          <a:xfrm>
+            <a:off x="566928" y="5074920"/>
+            <a:ext cx="11064240" cy="1143000"/>
+          </a:xfrm>
+          <a:prstGeom prst="roundRect">
+            <a:avLst>
+              <a:gd name="adj" fmla="val 7200"/>
+            </a:avLst>
+          </a:prstGeom>
+          <a:solidFill>
+            <a:srgbClr val="FEF6E0"/>
+          </a:solidFill>
+          <a:ln w="12700">
+            <a:solidFill>
+              <a:srgbClr val="FFFFFF"/>
+            </a:solidFill>
+            <a:prstDash val="solid"/>
+          </a:ln>
+        </p:spPr>
+      </p:sp>
+      <p:sp>
+        <p:nvSpPr>
+          <p:cNvPr id="20" name="Text 18"/>
+          <p:cNvSpPr/>
+          <p:nvPr/>
+        </p:nvSpPr>
+        <p:spPr>
+          <a:xfrm>
+            <a:off x="841248" y="5257800"/>
+            <a:ext cx="2743200" cy="256032"/>
+          </a:xfrm>
+          <a:prstGeom prst="rect">
+            <a:avLst/>
+          </a:prstGeom>
+          <a:noFill/>
+          <a:ln/>
+        </p:spPr>
+        <p:txBody>
+          <a:bodyPr wrap="square" lIns="0" tIns="0" rIns="0" bIns="0" rtlCol="0" anchor="ctr"/>
+          <a:lstStyle/>
+          <a:p>
+            <a:pPr indent="0" marL="0">
+              <a:buNone/>
+            </a:pPr>
+            <a:r>
+              <a:rPr lang="en-US" sz="1050" b="1" spc="130" kern="0" dirty="0">
+                <a:solidFill>
+                  <a:srgbClr val="A16207"/>
+                </a:solidFill>
+                <a:latin typeface="Calibri" pitchFamily="34" charset="0"/>
+                <a:ea typeface="Calibri" pitchFamily="34" charset="-122"/>
+                <a:cs typeface="Calibri" pitchFamily="34" charset="-120"/>
+              </a:rPr>
+              <a:t>PLAN AROUND THESE DATES</a:t>
+            </a:r>
+            <a:endParaRPr lang="en-US" sz="1050" dirty="0"/>
+          </a:p>
+        </p:txBody>
+      </p:sp>
+      <p:sp>
+        <p:nvSpPr>
+          <p:cNvPr id="21" name="Text 19"/>
+          <p:cNvSpPr/>
+          <p:nvPr/>
+        </p:nvSpPr>
+        <p:spPr>
+          <a:xfrm>
+            <a:off x="841248" y="5550408"/>
+            <a:ext cx="10515600" cy="521208"/>
+          </a:xfrm>
+          <a:prstGeom prst="rect">
+            <a:avLst/>
+          </a:prstGeom>
+          <a:noFill/>
+          <a:ln/>
+        </p:spPr>
+        <p:txBody>
+          <a:bodyPr wrap="square" lIns="0" tIns="0" rIns="0" bIns="0" rtlCol="0" anchor="ctr"/>
+          <a:lstStyle/>
+          <a:p>
+            <a:pPr indent="0" marL="0">
+              <a:lnSpc>
+                <a:spcPts val="2100"/>
+              </a:lnSpc>
+              <a:buNone/>
+            </a:pPr>
+            <a:r>
+              <a:rPr lang="en-US" sz="1400" dirty="0">
+                <a:solidFill>
+                  <a:srgbClr val="1F2937"/>
+                </a:solidFill>
+                <a:latin typeface="Calibri" pitchFamily="34" charset="0"/>
+                <a:ea typeface="Calibri" pitchFamily="34" charset="-122"/>
+                <a:cs typeface="Calibri" pitchFamily="34" charset="-120"/>
+              </a:rPr>
+              <a:t>Each is offline and individual. Practical 3 is deliberately a safety net, so a bad day earlier in the term is recoverable. But that only works if the earlier practicals are done, which is why I keep saying not to fall behind in Unit 3.</a:t>
+            </a:r>
+            <a:endParaRPr lang="en-US" sz="1400" dirty="0"/>
+          </a:p>
+        </p:txBody>
+      </p:sp>
+    </p:spTree>
+  </p:cSld>
+  <p:clrMapOvr>
+    <a:masterClrMapping/>
+  </p:clrMapOvr>
+</p:sld>
+</file>
+
+<file path=ppt/slides/slide53.xml><?xml version="1.0" encoding="utf-8"?>
+<p:sld xmlns:a="http://schemas.openxmlformats.org/drawingml/2006/main" xmlns:r="http://schemas.openxmlformats.org/officeDocument/2006/relationships" xmlns:p="http://schemas.openxmlformats.org/presentationml/2006/main">
+  <p:cSld name="Slide 53">
+    <p:bg>
+      <p:bgPr>
+        <a:solidFill>
+          <a:srgbClr val="FFFFFF"/>
+        </a:solidFill>
+      </p:bgPr>
+    </p:bg>
+    <p:spTree>
+      <p:nvGrpSpPr>
+        <p:cNvPr id="1" name=""/>
+        <p:cNvGrpSpPr/>
+        <p:nvPr/>
+      </p:nvGrpSpPr>
+      <p:grpSpPr>
+        <a:xfrm>
+          <a:off x="0" y="0"/>
+          <a:ext cx="0" cy="0"/>
+          <a:chOff x="0" y="0"/>
+          <a:chExt cx="0" cy="0"/>
+        </a:xfrm>
+      </p:grpSpPr>
+      <p:sp>
+        <p:nvSpPr>
+          <p:cNvPr id="2" name="Text 0"/>
+          <p:cNvSpPr/>
+          <p:nvPr/>
+        </p:nvSpPr>
+        <p:spPr>
+          <a:xfrm>
+            <a:off x="566928" y="502920"/>
+            <a:ext cx="11064240" cy="640080"/>
+          </a:xfrm>
+          <a:prstGeom prst="rect">
+            <a:avLst/>
+          </a:prstGeom>
+          <a:noFill/>
+          <a:ln/>
+        </p:spPr>
+        <p:txBody>
+          <a:bodyPr wrap="square" lIns="0" tIns="0" rIns="0" bIns="0" rtlCol="0" anchor="ctr"/>
+          <a:lstStyle/>
+          <a:p>
+            <a:pPr indent="0" marL="0">
+              <a:buNone/>
+            </a:pPr>
+            <a:r>
+              <a:rPr lang="en-US" sz="2900" b="1" dirty="0">
+                <a:solidFill>
+                  <a:srgbClr val="1F2937"/>
+                </a:solidFill>
+                <a:latin typeface="Cambria" pitchFamily="34" charset="0"/>
+                <a:ea typeface="Cambria" pitchFamily="34" charset="-122"/>
+                <a:cs typeface="Cambria" pitchFamily="34" charset="-120"/>
+              </a:rPr>
+              <a:t>Where everything lives</a:t>
+            </a:r>
+            <a:endParaRPr lang="en-US" sz="2900" dirty="0"/>
+          </a:p>
+        </p:txBody>
+      </p:sp>
+      <p:sp>
+        <p:nvSpPr>
+          <p:cNvPr id="3" name="Shape 1"/>
+          <p:cNvSpPr/>
+          <p:nvPr/>
+        </p:nvSpPr>
+        <p:spPr>
+          <a:xfrm>
+            <a:off x="566928" y="1874520"/>
+            <a:ext cx="3493008" cy="2468880"/>
+          </a:xfrm>
+          <a:prstGeom prst="roundRect">
+            <a:avLst>
+              <a:gd name="adj" fmla="val 3333"/>
+            </a:avLst>
+          </a:prstGeom>
+          <a:solidFill>
+            <a:srgbClr val="E6FBF7"/>
+          </a:solidFill>
+          <a:ln w="12700">
+            <a:solidFill>
+              <a:srgbClr val="FFFFFF"/>
+            </a:solidFill>
+            <a:prstDash val="solid"/>
+          </a:ln>
+        </p:spPr>
+      </p:sp>
+      <p:sp>
+        <p:nvSpPr>
+          <p:cNvPr id="4" name="Text 2"/>
+          <p:cNvSpPr/>
+          <p:nvPr/>
+        </p:nvSpPr>
+        <p:spPr>
+          <a:xfrm>
+            <a:off x="804672" y="2075688"/>
+            <a:ext cx="3035808" cy="256032"/>
+          </a:xfrm>
+          <a:prstGeom prst="rect">
+            <a:avLst/>
+          </a:prstGeom>
+          <a:noFill/>
+          <a:ln/>
+        </p:spPr>
+        <p:txBody>
+          <a:bodyPr wrap="square" lIns="0" tIns="0" rIns="0" bIns="0" rtlCol="0" anchor="ctr"/>
+          <a:lstStyle/>
+          <a:p>
+            <a:pPr indent="0" marL="0">
+              <a:buNone/>
+            </a:pPr>
+            <a:r>
+              <a:rPr lang="en-US" sz="1050" b="1" spc="120" kern="0" dirty="0">
+                <a:solidFill>
+                  <a:srgbClr val="0F766E"/>
+                </a:solidFill>
+                <a:latin typeface="Calibri" pitchFamily="34" charset="0"/>
+                <a:ea typeface="Calibri" pitchFamily="34" charset="-122"/>
+                <a:cs typeface="Calibri" pitchFamily="34" charset="-120"/>
+              </a:rPr>
+              <a:t>CODE</a:t>
+            </a:r>
+            <a:endParaRPr lang="en-US" sz="1050" dirty="0"/>
+          </a:p>
+        </p:txBody>
+      </p:sp>
+      <p:sp>
+        <p:nvSpPr>
+          <p:cNvPr id="5" name="Text 3"/>
+          <p:cNvSpPr/>
+          <p:nvPr/>
+        </p:nvSpPr>
+        <p:spPr>
+          <a:xfrm>
+            <a:off x="804672" y="2386584"/>
+            <a:ext cx="3035808" cy="548640"/>
+          </a:xfrm>
+          <a:prstGeom prst="rect">
+            <a:avLst/>
+          </a:prstGeom>
+          <a:noFill/>
+          <a:ln/>
+        </p:spPr>
+        <p:txBody>
+          <a:bodyPr wrap="square" lIns="0" tIns="0" rIns="0" bIns="0" rtlCol="0" anchor="ctr"/>
+          <a:lstStyle/>
+          <a:p>
+            <a:pPr indent="0" marL="0">
+              <a:lnSpc>
+                <a:spcPts val="2100"/>
+              </a:lnSpc>
+              <a:buNone/>
+            </a:pPr>
+            <a:r>
+              <a:rPr lang="en-US" sz="1700" b="1" dirty="0">
+                <a:solidFill>
+                  <a:srgbClr val="1F2937"/>
+                </a:solidFill>
+                <a:latin typeface="Cambria" pitchFamily="34" charset="0"/>
+                <a:ea typeface="Cambria" pitchFamily="34" charset="-122"/>
+                <a:cs typeface="Cambria" pitchFamily="34" charset="-120"/>
+              </a:rPr>
+              <a:t>The repository</a:t>
+            </a:r>
+            <a:endParaRPr lang="en-US" sz="1700" dirty="0"/>
+          </a:p>
+        </p:txBody>
+      </p:sp>
+      <p:sp>
+        <p:nvSpPr>
+          <p:cNvPr id="6" name="Text 4"/>
+          <p:cNvSpPr/>
+          <p:nvPr/>
+        </p:nvSpPr>
+        <p:spPr>
+          <a:xfrm>
+            <a:off x="804672" y="2953512"/>
+            <a:ext cx="3035808" cy="1188720"/>
+          </a:xfrm>
+          <a:prstGeom prst="rect">
+            <a:avLst/>
+          </a:prstGeom>
+          <a:noFill/>
+          <a:ln/>
+        </p:spPr>
+        <p:txBody>
+          <a:bodyPr wrap="square" lIns="0" tIns="0" rIns="0" bIns="0" rtlCol="0" anchor="ctr"/>
+          <a:lstStyle/>
+          <a:p>
+            <a:pPr indent="0" marL="0">
+              <a:lnSpc>
+                <a:spcPts val="1900"/>
+              </a:lnSpc>
+              <a:buNone/>
+            </a:pPr>
+            <a:r>
+              <a:rPr lang="en-US" sz="1350" dirty="0">
+                <a:solidFill>
+                  <a:srgbClr val="6B7280"/>
+                </a:solidFill>
+                <a:latin typeface="Calibri" pitchFamily="34" charset="0"/>
+                <a:ea typeface="Calibri" pitchFamily="34" charset="-122"/>
+                <a:cs typeface="Calibri" pitchFamily="34" charset="-120"/>
+              </a:rPr>
+              <a:t>Every notebook, every practical, the setup script, and the requirements file. Cloned once, pulled before each session.</a:t>
+            </a:r>
+            <a:endParaRPr lang="en-US" sz="1350" dirty="0"/>
+          </a:p>
+        </p:txBody>
+      </p:sp>
+      <p:sp>
+        <p:nvSpPr>
+          <p:cNvPr id="7" name="Shape 5"/>
+          <p:cNvSpPr/>
+          <p:nvPr/>
+        </p:nvSpPr>
+        <p:spPr>
+          <a:xfrm>
+            <a:off x="4352544" y="1874520"/>
+            <a:ext cx="3493008" cy="2468880"/>
+          </a:xfrm>
+          <a:prstGeom prst="roundRect">
+            <a:avLst>
+              <a:gd name="adj" fmla="val 3333"/>
+            </a:avLst>
+          </a:prstGeom>
+          <a:solidFill>
+            <a:srgbClr val="ECEBFB"/>
+          </a:solidFill>
+          <a:ln w="12700">
+            <a:solidFill>
+              <a:srgbClr val="FFFFFF"/>
+            </a:solidFill>
+            <a:prstDash val="solid"/>
+          </a:ln>
+        </p:spPr>
+      </p:sp>
+      <p:sp>
+        <p:nvSpPr>
+          <p:cNvPr id="8" name="Text 6"/>
+          <p:cNvSpPr/>
+          <p:nvPr/>
+        </p:nvSpPr>
+        <p:spPr>
+          <a:xfrm>
+            <a:off x="4590288" y="2075688"/>
+            <a:ext cx="3035808" cy="256032"/>
+          </a:xfrm>
+          <a:prstGeom prst="rect">
+            <a:avLst/>
+          </a:prstGeom>
+          <a:noFill/>
+          <a:ln/>
+        </p:spPr>
+        <p:txBody>
+          <a:bodyPr wrap="square" lIns="0" tIns="0" rIns="0" bIns="0" rtlCol="0" anchor="ctr"/>
+          <a:lstStyle/>
+          <a:p>
+            <a:pPr indent="0" marL="0">
+              <a:buNone/>
+            </a:pPr>
+            <a:r>
+              <a:rPr lang="en-US" sz="1050" b="1" spc="120" kern="0" dirty="0">
+                <a:solidFill>
+                  <a:srgbClr val="3730A3"/>
+                </a:solidFill>
+                <a:latin typeface="Calibri" pitchFamily="34" charset="0"/>
+                <a:ea typeface="Calibri" pitchFamily="34" charset="-122"/>
+                <a:cs typeface="Calibri" pitchFamily="34" charset="-120"/>
+              </a:rPr>
+              <a:t>SLIDES</a:t>
+            </a:r>
+            <a:endParaRPr lang="en-US" sz="1050" dirty="0"/>
+          </a:p>
+        </p:txBody>
+      </p:sp>
+      <p:sp>
+        <p:nvSpPr>
+          <p:cNvPr id="9" name="Text 7"/>
+          <p:cNvSpPr/>
+          <p:nvPr/>
+        </p:nvSpPr>
+        <p:spPr>
+          <a:xfrm>
+            <a:off x="4590288" y="2386584"/>
+            <a:ext cx="3035808" cy="548640"/>
+          </a:xfrm>
+          <a:prstGeom prst="rect">
+            <a:avLst/>
+          </a:prstGeom>
+          <a:noFill/>
+          <a:ln/>
+        </p:spPr>
+        <p:txBody>
+          <a:bodyPr wrap="square" lIns="0" tIns="0" rIns="0" bIns="0" rtlCol="0" anchor="ctr"/>
+          <a:lstStyle/>
+          <a:p>
+            <a:pPr indent="0" marL="0">
+              <a:lnSpc>
+                <a:spcPts val="2100"/>
+              </a:lnSpc>
+              <a:buNone/>
+            </a:pPr>
+            <a:r>
+              <a:rPr lang="en-US" sz="1700" b="1" dirty="0">
+                <a:solidFill>
+                  <a:srgbClr val="1F2937"/>
+                </a:solidFill>
+                <a:latin typeface="Cambria" pitchFamily="34" charset="0"/>
+                <a:ea typeface="Cambria" pitchFamily="34" charset="-122"/>
+                <a:cs typeface="Cambria" pitchFamily="34" charset="-120"/>
+              </a:rPr>
+              <a:t>Decks and handouts</a:t>
+            </a:r>
+            <a:endParaRPr lang="en-US" sz="1700" dirty="0"/>
+          </a:p>
+        </p:txBody>
+      </p:sp>
+      <p:sp>
+        <p:nvSpPr>
+          <p:cNvPr id="10" name="Text 8"/>
+          <p:cNvSpPr/>
+          <p:nvPr/>
+        </p:nvSpPr>
+        <p:spPr>
+          <a:xfrm>
+            <a:off x="4590288" y="2953512"/>
+            <a:ext cx="3035808" cy="1188720"/>
+          </a:xfrm>
+          <a:prstGeom prst="rect">
+            <a:avLst/>
+          </a:prstGeom>
+          <a:noFill/>
+          <a:ln/>
+        </p:spPr>
+        <p:txBody>
+          <a:bodyPr wrap="square" lIns="0" tIns="0" rIns="0" bIns="0" rtlCol="0" anchor="ctr"/>
+          <a:lstStyle/>
+          <a:p>
+            <a:pPr indent="0" marL="0">
+              <a:lnSpc>
+                <a:spcPts val="1900"/>
+              </a:lnSpc>
+              <a:buNone/>
+            </a:pPr>
+            <a:r>
+              <a:rPr lang="en-US" sz="1350" dirty="0">
+                <a:solidFill>
+                  <a:srgbClr val="6B7280"/>
+                </a:solidFill>
+                <a:latin typeface="Calibri" pitchFamily="34" charset="0"/>
+                <a:ea typeface="Calibri" pitchFamily="34" charset="-122"/>
+                <a:cs typeface="Calibri" pitchFamily="34" charset="-120"/>
+              </a:rPr>
+              <a:t>Each session ships a deck and a collapsed handout you can read without the slides.</a:t>
+            </a:r>
+            <a:endParaRPr lang="en-US" sz="1350" dirty="0"/>
+          </a:p>
+        </p:txBody>
+      </p:sp>
+      <p:sp>
+        <p:nvSpPr>
+          <p:cNvPr id="11" name="Shape 9"/>
+          <p:cNvSpPr/>
+          <p:nvPr/>
+        </p:nvSpPr>
+        <p:spPr>
+          <a:xfrm>
+            <a:off x="8138160" y="1874520"/>
+            <a:ext cx="3493008" cy="2468880"/>
+          </a:xfrm>
+          <a:prstGeom prst="roundRect">
+            <a:avLst>
+              <a:gd name="adj" fmla="val 3333"/>
+            </a:avLst>
+          </a:prstGeom>
+          <a:solidFill>
+            <a:srgbClr val="FEF6E0"/>
+          </a:solidFill>
+          <a:ln w="12700">
+            <a:solidFill>
+              <a:srgbClr val="FFFFFF"/>
+            </a:solidFill>
+            <a:prstDash val="solid"/>
+          </a:ln>
+        </p:spPr>
+      </p:sp>
+      <p:sp>
+        <p:nvSpPr>
+          <p:cNvPr id="12" name="Text 10"/>
+          <p:cNvSpPr/>
+          <p:nvPr/>
+        </p:nvSpPr>
+        <p:spPr>
+          <a:xfrm>
+            <a:off x="8375904" y="2075688"/>
+            <a:ext cx="3035808" cy="256032"/>
+          </a:xfrm>
+          <a:prstGeom prst="rect">
+            <a:avLst/>
+          </a:prstGeom>
+          <a:noFill/>
+          <a:ln/>
+        </p:spPr>
+        <p:txBody>
+          <a:bodyPr wrap="square" lIns="0" tIns="0" rIns="0" bIns="0" rtlCol="0" anchor="ctr"/>
+          <a:lstStyle/>
+          <a:p>
+            <a:pPr indent="0" marL="0">
+              <a:buNone/>
+            </a:pPr>
+            <a:r>
+              <a:rPr lang="en-US" sz="1050" b="1" spc="120" kern="0" dirty="0">
+                <a:solidFill>
+                  <a:srgbClr val="A16207"/>
+                </a:solidFill>
+                <a:latin typeface="Calibri" pitchFamily="34" charset="0"/>
+                <a:ea typeface="Calibri" pitchFamily="34" charset="-122"/>
+                <a:cs typeface="Calibri" pitchFamily="34" charset="-120"/>
+              </a:rPr>
+              <a:t>HELP</a:t>
+            </a:r>
+            <a:endParaRPr lang="en-US" sz="1050" dirty="0"/>
+          </a:p>
+        </p:txBody>
+      </p:sp>
+      <p:sp>
+        <p:nvSpPr>
+          <p:cNvPr id="13" name="Text 11"/>
+          <p:cNvSpPr/>
+          <p:nvPr/>
+        </p:nvSpPr>
+        <p:spPr>
+          <a:xfrm>
+            <a:off x="8375904" y="2386584"/>
+            <a:ext cx="3035808" cy="548640"/>
+          </a:xfrm>
+          <a:prstGeom prst="rect">
+            <a:avLst/>
+          </a:prstGeom>
+          <a:noFill/>
+          <a:ln/>
+        </p:spPr>
+        <p:txBody>
+          <a:bodyPr wrap="square" lIns="0" tIns="0" rIns="0" bIns="0" rtlCol="0" anchor="ctr"/>
+          <a:lstStyle/>
+          <a:p>
+            <a:pPr indent="0" marL="0">
+              <a:lnSpc>
+                <a:spcPts val="2100"/>
+              </a:lnSpc>
+              <a:buNone/>
+            </a:pPr>
+            <a:r>
+              <a:rPr lang="en-US" sz="1700" b="1" dirty="0">
+                <a:solidFill>
+                  <a:srgbClr val="1F2937"/>
+                </a:solidFill>
+                <a:latin typeface="Cambria" pitchFamily="34" charset="0"/>
+                <a:ea typeface="Cambria" pitchFamily="34" charset="-122"/>
+                <a:cs typeface="Cambria" pitchFamily="34" charset="-120"/>
+              </a:rPr>
+              <a:t>The course channel</a:t>
+            </a:r>
+            <a:endParaRPr lang="en-US" sz="1700" dirty="0"/>
+          </a:p>
+        </p:txBody>
+      </p:sp>
+      <p:sp>
+        <p:nvSpPr>
+          <p:cNvPr id="14" name="Text 12"/>
+          <p:cNvSpPr/>
+          <p:nvPr/>
+        </p:nvSpPr>
+        <p:spPr>
+          <a:xfrm>
+            <a:off x="8375904" y="2953512"/>
+            <a:ext cx="3035808" cy="1188720"/>
+          </a:xfrm>
+          <a:prstGeom prst="rect">
+            <a:avLst/>
+          </a:prstGeom>
+          <a:noFill/>
+          <a:ln/>
+        </p:spPr>
+        <p:txBody>
+          <a:bodyPr wrap="square" lIns="0" tIns="0" rIns="0" bIns="0" rtlCol="0" anchor="ctr"/>
+          <a:lstStyle/>
+          <a:p>
+            <a:pPr indent="0" marL="0">
+              <a:lnSpc>
+                <a:spcPts val="1900"/>
+              </a:lnSpc>
+              <a:buNone/>
+            </a:pPr>
+            <a:r>
+              <a:rPr lang="en-US" sz="1350" dirty="0">
+                <a:solidFill>
+                  <a:srgbClr val="6B7280"/>
+                </a:solidFill>
+                <a:latin typeface="Calibri" pitchFamily="34" charset="0"/>
+                <a:ea typeface="Calibri" pitchFamily="34" charset="-122"/>
+                <a:cs typeface="Calibri" pitchFamily="34" charset="-120"/>
+              </a:rPr>
+              <a:t>Post the exact error, not "it is not working". Screenshot the full traceback. Somebody will have hit it already.</a:t>
+            </a:r>
+            <a:endParaRPr lang="en-US" sz="1350" dirty="0"/>
+          </a:p>
+        </p:txBody>
+      </p:sp>
+      <p:sp>
+        <p:nvSpPr>
+          <p:cNvPr id="15" name="Shape 13"/>
+          <p:cNvSpPr/>
+          <p:nvPr/>
+        </p:nvSpPr>
+        <p:spPr>
+          <a:xfrm>
+            <a:off x="566928" y="4617720"/>
+            <a:ext cx="11064240" cy="1005840"/>
+          </a:xfrm>
+          <a:prstGeom prst="roundRect">
+            <a:avLst>
+              <a:gd name="adj" fmla="val 8182"/>
+            </a:avLst>
+          </a:prstGeom>
+          <a:solidFill>
+            <a:srgbClr val="E6FBF7"/>
+          </a:solidFill>
+          <a:ln w="12700">
+            <a:solidFill>
+              <a:srgbClr val="FFFFFF"/>
+            </a:solidFill>
+            <a:prstDash val="solid"/>
+          </a:ln>
+        </p:spPr>
+      </p:sp>
+      <p:sp>
+        <p:nvSpPr>
+          <p:cNvPr id="16" name="Text 14"/>
+          <p:cNvSpPr/>
+          <p:nvPr/>
+        </p:nvSpPr>
+        <p:spPr>
+          <a:xfrm>
+            <a:off x="841248" y="4800600"/>
+            <a:ext cx="3657600" cy="256032"/>
+          </a:xfrm>
+          <a:prstGeom prst="rect">
+            <a:avLst/>
+          </a:prstGeom>
+          <a:noFill/>
+          <a:ln/>
+        </p:spPr>
+        <p:txBody>
+          <a:bodyPr wrap="square" lIns="0" tIns="0" rIns="0" bIns="0" rtlCol="0" anchor="ctr"/>
+          <a:lstStyle/>
+          <a:p>
+            <a:pPr indent="0" marL="0">
+              <a:buNone/>
+            </a:pPr>
+            <a:r>
+              <a:rPr lang="en-US" sz="1050" b="1" spc="130" kern="0" dirty="0">
+                <a:solidFill>
+                  <a:srgbClr val="0F766E"/>
+                </a:solidFill>
+                <a:latin typeface="Calibri" pitchFamily="34" charset="0"/>
+                <a:ea typeface="Calibri" pitchFamily="34" charset="-122"/>
+                <a:cs typeface="Calibri" pitchFamily="34" charset="-120"/>
+              </a:rPr>
+              <a:t>RIGHT NOW, BEFORE YOU LEAVE</a:t>
+            </a:r>
+            <a:endParaRPr lang="en-US" sz="1050" dirty="0"/>
+          </a:p>
+        </p:txBody>
+      </p:sp>
+      <p:sp>
+        <p:nvSpPr>
+          <p:cNvPr id="17" name="Text 15"/>
+          <p:cNvSpPr/>
+          <p:nvPr/>
+        </p:nvSpPr>
+        <p:spPr>
+          <a:xfrm>
+            <a:off x="841248" y="5093208"/>
+            <a:ext cx="10515600" cy="384048"/>
+          </a:xfrm>
+          <a:prstGeom prst="rect">
+            <a:avLst/>
+          </a:prstGeom>
+          <a:noFill/>
+          <a:ln/>
+        </p:spPr>
+        <p:txBody>
+          <a:bodyPr wrap="square" lIns="0" tIns="0" rIns="0" bIns="0" rtlCol="0" anchor="ctr"/>
+          <a:lstStyle/>
+          <a:p>
+            <a:pPr indent="0" marL="0">
+              <a:lnSpc>
+                <a:spcPts val="2100"/>
+              </a:lnSpc>
+              <a:buNone/>
+            </a:pPr>
+            <a:r>
+              <a:rPr lang="en-US" sz="1500" dirty="0">
+                <a:solidFill>
+                  <a:srgbClr val="1F2937"/>
+                </a:solidFill>
+                <a:latin typeface="Calibri" pitchFamily="34" charset="0"/>
+                <a:ea typeface="Calibri" pitchFamily="34" charset="-122"/>
+                <a:cs typeface="Calibri" pitchFamily="34" charset="-120"/>
+              </a:rPr>
+              <a:t>Take out your phone and note the repository link on the next slide. Do the clone tonight, not on the morning of the first practical.</a:t>
+            </a:r>
+            <a:endParaRPr lang="en-US" sz="1500" dirty="0"/>
+          </a:p>
+        </p:txBody>
+      </p:sp>
+    </p:spTree>
+  </p:cSld>
+  <p:clrMapOvr>
+    <a:masterClrMapping/>
+  </p:clrMapOvr>
+</p:sld>
+</file>
+
+<file path=ppt/slides/slide54.xml><?xml version="1.0" encoding="utf-8"?>
+<p:sld xmlns:a="http://schemas.openxmlformats.org/drawingml/2006/main" xmlns:r="http://schemas.openxmlformats.org/officeDocument/2006/relationships" xmlns:p="http://schemas.openxmlformats.org/presentationml/2006/main">
+  <p:cSld name="Slide 54">
+    <p:bg>
+      <p:bgPr>
+        <a:solidFill>
+          <a:srgbClr val="FFFFFF"/>
+        </a:solidFill>
+      </p:bgPr>
+    </p:bg>
+    <p:spTree>
+      <p:nvGrpSpPr>
+        <p:cNvPr id="1" name=""/>
+        <p:cNvGrpSpPr/>
+        <p:nvPr/>
+      </p:nvGrpSpPr>
+      <p:grpSpPr>
+        <a:xfrm>
+          <a:off x="0" y="0"/>
+          <a:ext cx="0" cy="0"/>
+          <a:chOff x="0" y="0"/>
+          <a:chExt cx="0" cy="0"/>
+        </a:xfrm>
+      </p:grpSpPr>
+      <p:sp>
+        <p:nvSpPr>
+          <p:cNvPr id="2" name="Text 0"/>
+          <p:cNvSpPr/>
+          <p:nvPr/>
+        </p:nvSpPr>
+        <p:spPr>
+          <a:xfrm>
+            <a:off x="566928" y="502920"/>
+            <a:ext cx="11064240" cy="640080"/>
+          </a:xfrm>
+          <a:prstGeom prst="rect">
+            <a:avLst/>
+          </a:prstGeom>
+          <a:noFill/>
+          <a:ln/>
+        </p:spPr>
+        <p:txBody>
+          <a:bodyPr wrap="square" lIns="0" tIns="0" rIns="0" bIns="0" rtlCol="0" anchor="ctr"/>
+          <a:lstStyle/>
+          <a:p>
+            <a:pPr indent="0" marL="0">
+              <a:buNone/>
+            </a:pPr>
+            <a:r>
+              <a:rPr lang="en-US" sz="2900" b="1" dirty="0">
+                <a:solidFill>
+                  <a:srgbClr val="1F2937"/>
+                </a:solidFill>
+                <a:latin typeface="Cambria" pitchFamily="34" charset="0"/>
+                <a:ea typeface="Cambria" pitchFamily="34" charset="-122"/>
+                <a:cs typeface="Cambria" pitchFamily="34" charset="-120"/>
+              </a:rPr>
+              <a:t>What you will be able to say in December</a:t>
+            </a:r>
+            <a:endParaRPr lang="en-US" sz="2900" dirty="0"/>
+          </a:p>
+        </p:txBody>
+      </p:sp>
+      <p:sp>
+        <p:nvSpPr>
+          <p:cNvPr id="3" name="Text 1"/>
+          <p:cNvSpPr/>
+          <p:nvPr/>
+        </p:nvSpPr>
+        <p:spPr>
+          <a:xfrm>
+            <a:off x="566928" y="1554480"/>
+            <a:ext cx="10607040" cy="457200"/>
+          </a:xfrm>
+          <a:prstGeom prst="rect">
+            <a:avLst/>
+          </a:prstGeom>
+          <a:noFill/>
+          <a:ln/>
+        </p:spPr>
+        <p:txBody>
+          <a:bodyPr wrap="square" lIns="0" tIns="0" rIns="0" bIns="0" rtlCol="0" anchor="ctr"/>
+          <a:lstStyle/>
+          <a:p>
+            <a:pPr algn="l" indent="0" marL="0">
+              <a:lnSpc>
+                <a:spcPts val="2700"/>
+              </a:lnSpc>
+              <a:buNone/>
+            </a:pPr>
+            <a:r>
+              <a:rPr lang="en-US" sz="1700" dirty="0">
+                <a:solidFill>
+                  <a:srgbClr val="6B7280"/>
+                </a:solidFill>
+                <a:latin typeface="Calibri" pitchFamily="34" charset="0"/>
+                <a:ea typeface="Calibri" pitchFamily="34" charset="-122"/>
+                <a:cs typeface="Calibri" pitchFamily="34" charset="-120"/>
+              </a:rPr>
+              <a:t>Not "I did a course on AI agents." Anybody can say that.</a:t>
+            </a:r>
+            <a:endParaRPr lang="en-US" sz="1700" dirty="0"/>
+          </a:p>
+        </p:txBody>
+      </p:sp>
+      <p:sp>
+        <p:nvSpPr>
+          <p:cNvPr id="4" name="Shape 2"/>
+          <p:cNvSpPr/>
+          <p:nvPr/>
+        </p:nvSpPr>
+        <p:spPr>
+          <a:xfrm>
+            <a:off x="566928" y="2194560"/>
+            <a:ext cx="11064240" cy="2286000"/>
+          </a:xfrm>
+          <a:prstGeom prst="roundRect">
+            <a:avLst>
+              <a:gd name="adj" fmla="val 4800"/>
+            </a:avLst>
+          </a:prstGeom>
+          <a:solidFill>
+            <a:srgbClr val="E6FBF7"/>
+          </a:solidFill>
+          <a:ln w="12700">
+            <a:solidFill>
+              <a:srgbClr val="FFFFFF"/>
+            </a:solidFill>
+            <a:prstDash val="solid"/>
+          </a:ln>
+        </p:spPr>
+      </p:sp>
+      <p:sp>
+        <p:nvSpPr>
+          <p:cNvPr id="5" name="Text 3"/>
+          <p:cNvSpPr/>
+          <p:nvPr/>
+        </p:nvSpPr>
+        <p:spPr>
+          <a:xfrm>
+            <a:off x="1051560" y="2194560"/>
+            <a:ext cx="10104120" cy="2286000"/>
+          </a:xfrm>
+          <a:prstGeom prst="rect">
+            <a:avLst/>
+          </a:prstGeom>
+          <a:noFill/>
+          <a:ln/>
+        </p:spPr>
+        <p:txBody>
+          <a:bodyPr wrap="square" lIns="0" tIns="0" rIns="0" bIns="0" rtlCol="0" anchor="ctr"/>
+          <a:lstStyle/>
+          <a:p>
+            <a:pPr indent="0" marL="0">
+              <a:lnSpc>
+                <a:spcPts val="3200"/>
+              </a:lnSpc>
+              <a:buNone/>
+            </a:pPr>
+            <a:r>
+              <a:rPr lang="en-US" sz="2100" b="1" dirty="0">
+                <a:solidFill>
+                  <a:srgbClr val="1F2937"/>
+                </a:solidFill>
+                <a:latin typeface="Cambria" pitchFamily="34" charset="0"/>
+                <a:ea typeface="Cambria" pitchFamily="34" charset="-122"/>
+                <a:cs typeface="Cambria" pitchFamily="34" charset="-120"/>
+              </a:rPr>
+              <a:t>"I built a multi agent system. Here is the live link. It is instrumented, so here is a trace of a real request. It runs with least privilege, so here is what it is not allowed to touch. It caught a prompt injection during testing, and here is the fix I wrote for it."</a:t>
+            </a:r>
+            <a:endParaRPr lang="en-US" sz="2100" dirty="0"/>
+          </a:p>
+        </p:txBody>
+      </p:sp>
+      <p:sp>
+        <p:nvSpPr>
+          <p:cNvPr id="6" name="Text 4"/>
+          <p:cNvSpPr/>
+          <p:nvPr/>
+        </p:nvSpPr>
+        <p:spPr>
+          <a:xfrm>
+            <a:off x="566928" y="4846320"/>
+            <a:ext cx="10607040" cy="640080"/>
+          </a:xfrm>
+          <a:prstGeom prst="rect">
+            <a:avLst/>
+          </a:prstGeom>
+          <a:noFill/>
+          <a:ln/>
+        </p:spPr>
+        <p:txBody>
+          <a:bodyPr wrap="square" lIns="0" tIns="0" rIns="0" bIns="0" rtlCol="0" anchor="ctr"/>
+          <a:lstStyle/>
+          <a:p>
+            <a:pPr algn="l" indent="0" marL="0">
+              <a:lnSpc>
+                <a:spcPts val="2700"/>
+              </a:lnSpc>
+              <a:buNone/>
+            </a:pPr>
+            <a:r>
+              <a:rPr lang="en-US" sz="1700" dirty="0">
+                <a:solidFill>
+                  <a:srgbClr val="1F2937"/>
+                </a:solidFill>
+                <a:latin typeface="Calibri" pitchFamily="34" charset="0"/>
+                <a:ea typeface="Calibri" pitchFamily="34" charset="-122"/>
+                <a:cs typeface="Calibri" pitchFamily="34" charset="-120"/>
+              </a:rPr>
+              <a:t>That sentence is the entire point of the next fifty hours. Everything in the syllabus exists to make it true for you.</a:t>
+            </a:r>
+            <a:endParaRPr lang="en-US" sz="1700" dirty="0"/>
+          </a:p>
+        </p:txBody>
+      </p:sp>
+    </p:spTree>
+  </p:cSld>
+  <p:clrMapOvr>
+    <a:masterClrMapping/>
+  </p:clrMapOvr>
+</p:sld>
+</file>
+
+<file path=ppt/slides/slide55.xml><?xml version="1.0" encoding="utf-8"?>
+<p:sld xmlns:a="http://schemas.openxmlformats.org/drawingml/2006/main" xmlns:r="http://schemas.openxmlformats.org/officeDocument/2006/relationships" xmlns:p="http://schemas.openxmlformats.org/presentationml/2006/main">
+  <p:cSld name="Slide 55">
     <p:bg>
       <p:bgPr>
         <a:solidFill>

</xml_diff>